<commit_message>
Update PubMed lymphoma slides 2026-06-08
</commit_message>
<xml_diff>
--- a/archive/2026-06-08/pubmed-dlbcl-cnsl-btki-2026-06-08.pptx
+++ b/archive/2026-06-08/pubmed-dlbcl-cnsl-btki-2026-06-08.pptx
@@ -5,15 +5,21 @@
     <p:sldMasterId id="2147483648" r:id="rId1"/>
   </p:sldMasterIdLst>
   <p:sldIdLst>
-    <p:sldId id="256" r:id="rId2"/>
-    <p:sldId id="257" r:id="rId3"/>
-    <p:sldId id="258" r:id="rId4"/>
-    <p:sldId id="259" r:id="rId5"/>
-    <p:sldId id="260" r:id="rId6"/>
-    <p:sldId id="261" r:id="rId7"/>
-    <p:sldId id="262" r:id="rId8"/>
+    <p:sldId id="256" r:id="rId7"/>
+    <p:sldId id="257" r:id="rId8"/>
+    <p:sldId id="258" r:id="rId9"/>
+    <p:sldId id="259" r:id="rId10"/>
+    <p:sldId id="260" r:id="rId11"/>
+    <p:sldId id="261" r:id="rId12"/>
+    <p:sldId id="262" r:id="rId13"/>
+    <p:sldId id="263" r:id="rId14"/>
+    <p:sldId id="264" r:id="rId15"/>
+    <p:sldId id="265" r:id="rId16"/>
+    <p:sldId id="266" r:id="rId17"/>
+    <p:sldId id="267" r:id="rId18"/>
+    <p:sldId id="268" r:id="rId19"/>
   </p:sldIdLst>
-  <p:sldSz cx="12192000" cy="6858000"/>
+  <p:sldSz cx="12191999" cy="6858000" type="screen4x3"/>
   <p:notesSz cx="6858000" cy="9144000"/>
   <p:defaultTextStyle>
     <a:defPPr>
@@ -110,22 +116,6 @@
       </a:defRPr>
     </a:lvl9pPr>
   </p:defaultTextStyle>
-  <p:extLst>
-    <p:ext uri="{EFAFB233-063F-42B5-8137-9DF3F51BA10A}">
-      <p15:sldGuideLst xmlns:p15="http://schemas.microsoft.com/office/powerpoint/2012/main">
-        <p15:guide id="1" orient="horz" pos="2160">
-          <p15:clr>
-            <a:srgbClr val="A4A3A4"/>
-          </p15:clr>
-        </p15:guide>
-        <p15:guide id="2" pos="2880">
-          <p15:clr>
-            <a:srgbClr val="A4A3A4"/>
-          </p15:clr>
-        </p15:guide>
-      </p15:sldGuideLst>
-    </p:ext>
-  </p:extLst>
 </p:presentation>
 </file>
 
@@ -167,9 +157,10 @@
           <a:lstStyle/>
           <a:p>
             <a:r>
-              <a:rPr lang="en-US"/>
+              <a:rPr lang="en-US" smtClean="0"/>
               <a:t>Click to edit Master title style</a:t>
             </a:r>
+            <a:endParaRPr lang="en-US"/>
           </a:p>
         </p:txBody>
       </p:sp>
@@ -285,9 +276,10 @@
           </a:lstStyle>
           <a:p>
             <a:r>
-              <a:rPr lang="en-US"/>
+              <a:rPr lang="en-US" smtClean="0"/>
               <a:t>Click to edit Master subtitle style</a:t>
             </a:r>
+            <a:endParaRPr lang="en-US"/>
           </a:p>
         </p:txBody>
       </p:sp>
@@ -308,7 +300,7 @@
           <a:p>
             <a:fld id="{5BCAD085-E8A6-8845-BD4E-CB4CCA059FC4}" type="datetimeFigureOut">
               <a:rPr lang="en-US" smtClean="0"/>
-              <a:t>6/8/2026</a:t>
+              <a:t>1/27/13</a:t>
             </a:fld>
             <a:endParaRPr lang="en-US"/>
           </a:p>
@@ -402,9 +394,10 @@
           <a:lstStyle/>
           <a:p>
             <a:r>
-              <a:rPr lang="en-US"/>
+              <a:rPr lang="en-US" smtClean="0"/>
               <a:t>Click to edit Master title style</a:t>
             </a:r>
+            <a:endParaRPr lang="en-US"/>
           </a:p>
         </p:txBody>
       </p:sp>
@@ -425,37 +418,38 @@
           <a:p>
             <a:pPr lvl="0"/>
             <a:r>
-              <a:rPr lang="en-US"/>
+              <a:rPr lang="en-US" smtClean="0"/>
               <a:t>Click to edit Master text styles</a:t>
             </a:r>
           </a:p>
           <a:p>
             <a:pPr lvl="1"/>
             <a:r>
-              <a:rPr lang="en-US"/>
+              <a:rPr lang="en-US" smtClean="0"/>
               <a:t>Second level</a:t>
             </a:r>
           </a:p>
           <a:p>
             <a:pPr lvl="2"/>
             <a:r>
-              <a:rPr lang="en-US"/>
+              <a:rPr lang="en-US" smtClean="0"/>
               <a:t>Third level</a:t>
             </a:r>
           </a:p>
           <a:p>
             <a:pPr lvl="3"/>
             <a:r>
-              <a:rPr lang="en-US"/>
+              <a:rPr lang="en-US" smtClean="0"/>
               <a:t>Fourth level</a:t>
             </a:r>
           </a:p>
           <a:p>
             <a:pPr lvl="4"/>
             <a:r>
-              <a:rPr lang="en-US"/>
+              <a:rPr lang="en-US" smtClean="0"/>
               <a:t>Fifth level</a:t>
             </a:r>
+            <a:endParaRPr lang="en-US"/>
           </a:p>
         </p:txBody>
       </p:sp>
@@ -476,7 +470,7 @@
           <a:p>
             <a:fld id="{5BCAD085-E8A6-8845-BD4E-CB4CCA059FC4}" type="datetimeFigureOut">
               <a:rPr lang="en-US" smtClean="0"/>
-              <a:t>6/8/2026</a:t>
+              <a:t>1/27/13</a:t>
             </a:fld>
             <a:endParaRPr lang="en-US"/>
           </a:p>
@@ -575,9 +569,10 @@
           <a:lstStyle/>
           <a:p>
             <a:r>
-              <a:rPr lang="en-US"/>
+              <a:rPr lang="en-US" smtClean="0"/>
               <a:t>Click to edit Master title style</a:t>
             </a:r>
+            <a:endParaRPr lang="en-US"/>
           </a:p>
         </p:txBody>
       </p:sp>
@@ -603,37 +598,38 @@
           <a:p>
             <a:pPr lvl="0"/>
             <a:r>
-              <a:rPr lang="en-US"/>
+              <a:rPr lang="en-US" smtClean="0"/>
               <a:t>Click to edit Master text styles</a:t>
             </a:r>
           </a:p>
           <a:p>
             <a:pPr lvl="1"/>
             <a:r>
-              <a:rPr lang="en-US"/>
+              <a:rPr lang="en-US" smtClean="0"/>
               <a:t>Second level</a:t>
             </a:r>
           </a:p>
           <a:p>
             <a:pPr lvl="2"/>
             <a:r>
-              <a:rPr lang="en-US"/>
+              <a:rPr lang="en-US" smtClean="0"/>
               <a:t>Third level</a:t>
             </a:r>
           </a:p>
           <a:p>
             <a:pPr lvl="3"/>
             <a:r>
-              <a:rPr lang="en-US"/>
+              <a:rPr lang="en-US" smtClean="0"/>
               <a:t>Fourth level</a:t>
             </a:r>
           </a:p>
           <a:p>
             <a:pPr lvl="4"/>
             <a:r>
-              <a:rPr lang="en-US"/>
+              <a:rPr lang="en-US" smtClean="0"/>
               <a:t>Fifth level</a:t>
             </a:r>
+            <a:endParaRPr lang="en-US"/>
           </a:p>
         </p:txBody>
       </p:sp>
@@ -654,7 +650,7 @@
           <a:p>
             <a:fld id="{5BCAD085-E8A6-8845-BD4E-CB4CCA059FC4}" type="datetimeFigureOut">
               <a:rPr lang="en-US" smtClean="0"/>
-              <a:t>6/8/2026</a:t>
+              <a:t>1/27/13</a:t>
             </a:fld>
             <a:endParaRPr lang="en-US"/>
           </a:p>
@@ -748,9 +744,10 @@
           <a:lstStyle/>
           <a:p>
             <a:r>
-              <a:rPr lang="en-US"/>
+              <a:rPr lang="en-US" smtClean="0"/>
               <a:t>Click to edit Master title style</a:t>
             </a:r>
+            <a:endParaRPr lang="en-US"/>
           </a:p>
         </p:txBody>
       </p:sp>
@@ -771,37 +768,38 @@
           <a:p>
             <a:pPr lvl="0"/>
             <a:r>
-              <a:rPr lang="en-US"/>
+              <a:rPr lang="en-US" smtClean="0"/>
               <a:t>Click to edit Master text styles</a:t>
             </a:r>
           </a:p>
           <a:p>
             <a:pPr lvl="1"/>
             <a:r>
-              <a:rPr lang="en-US"/>
+              <a:rPr lang="en-US" smtClean="0"/>
               <a:t>Second level</a:t>
             </a:r>
           </a:p>
           <a:p>
             <a:pPr lvl="2"/>
             <a:r>
-              <a:rPr lang="en-US"/>
+              <a:rPr lang="en-US" smtClean="0"/>
               <a:t>Third level</a:t>
             </a:r>
           </a:p>
           <a:p>
             <a:pPr lvl="3"/>
             <a:r>
-              <a:rPr lang="en-US"/>
+              <a:rPr lang="en-US" smtClean="0"/>
               <a:t>Fourth level</a:t>
             </a:r>
           </a:p>
           <a:p>
             <a:pPr lvl="4"/>
             <a:r>
-              <a:rPr lang="en-US"/>
+              <a:rPr lang="en-US" smtClean="0"/>
               <a:t>Fifth level</a:t>
             </a:r>
+            <a:endParaRPr lang="en-US"/>
           </a:p>
         </p:txBody>
       </p:sp>
@@ -822,7 +820,7 @@
           <a:p>
             <a:fld id="{5BCAD085-E8A6-8845-BD4E-CB4CCA059FC4}" type="datetimeFigureOut">
               <a:rPr lang="en-US" smtClean="0"/>
-              <a:t>6/8/2026</a:t>
+              <a:t>1/27/13</a:t>
             </a:fld>
             <a:endParaRPr lang="en-US"/>
           </a:p>
@@ -925,9 +923,10 @@
           </a:lstStyle>
           <a:p>
             <a:r>
-              <a:rPr lang="en-US"/>
+              <a:rPr lang="en-US" smtClean="0"/>
               <a:t>Click to edit Master title style</a:t>
             </a:r>
+            <a:endParaRPr lang="en-US"/>
           </a:p>
         </p:txBody>
       </p:sp>
@@ -1044,7 +1043,7 @@
           <a:p>
             <a:pPr lvl="0"/>
             <a:r>
-              <a:rPr lang="en-US"/>
+              <a:rPr lang="en-US" smtClean="0"/>
               <a:t>Click to edit Master text styles</a:t>
             </a:r>
           </a:p>
@@ -1067,7 +1066,7 @@
           <a:p>
             <a:fld id="{5BCAD085-E8A6-8845-BD4E-CB4CCA059FC4}" type="datetimeFigureOut">
               <a:rPr lang="en-US" smtClean="0"/>
-              <a:t>6/8/2026</a:t>
+              <a:t>1/27/13</a:t>
             </a:fld>
             <a:endParaRPr lang="en-US"/>
           </a:p>
@@ -1161,9 +1160,10 @@
           <a:lstStyle/>
           <a:p>
             <a:r>
-              <a:rPr lang="en-US"/>
+              <a:rPr lang="en-US" smtClean="0"/>
               <a:t>Click to edit Master title style</a:t>
             </a:r>
+            <a:endParaRPr lang="en-US"/>
           </a:p>
         </p:txBody>
       </p:sp>
@@ -1217,37 +1217,38 @@
           <a:p>
             <a:pPr lvl="0"/>
             <a:r>
-              <a:rPr lang="en-US"/>
+              <a:rPr lang="en-US" smtClean="0"/>
               <a:t>Click to edit Master text styles</a:t>
             </a:r>
           </a:p>
           <a:p>
             <a:pPr lvl="1"/>
             <a:r>
-              <a:rPr lang="en-US"/>
+              <a:rPr lang="en-US" smtClean="0"/>
               <a:t>Second level</a:t>
             </a:r>
           </a:p>
           <a:p>
             <a:pPr lvl="2"/>
             <a:r>
-              <a:rPr lang="en-US"/>
+              <a:rPr lang="en-US" smtClean="0"/>
               <a:t>Third level</a:t>
             </a:r>
           </a:p>
           <a:p>
             <a:pPr lvl="3"/>
             <a:r>
-              <a:rPr lang="en-US"/>
+              <a:rPr lang="en-US" smtClean="0"/>
               <a:t>Fourth level</a:t>
             </a:r>
           </a:p>
           <a:p>
             <a:pPr lvl="4"/>
             <a:r>
-              <a:rPr lang="en-US"/>
+              <a:rPr lang="en-US" smtClean="0"/>
               <a:t>Fifth level</a:t>
             </a:r>
+            <a:endParaRPr lang="en-US"/>
           </a:p>
         </p:txBody>
       </p:sp>
@@ -1301,37 +1302,38 @@
           <a:p>
             <a:pPr lvl="0"/>
             <a:r>
-              <a:rPr lang="en-US"/>
+              <a:rPr lang="en-US" smtClean="0"/>
               <a:t>Click to edit Master text styles</a:t>
             </a:r>
           </a:p>
           <a:p>
             <a:pPr lvl="1"/>
             <a:r>
-              <a:rPr lang="en-US"/>
+              <a:rPr lang="en-US" smtClean="0"/>
               <a:t>Second level</a:t>
             </a:r>
           </a:p>
           <a:p>
             <a:pPr lvl="2"/>
             <a:r>
-              <a:rPr lang="en-US"/>
+              <a:rPr lang="en-US" smtClean="0"/>
               <a:t>Third level</a:t>
             </a:r>
           </a:p>
           <a:p>
             <a:pPr lvl="3"/>
             <a:r>
-              <a:rPr lang="en-US"/>
+              <a:rPr lang="en-US" smtClean="0"/>
               <a:t>Fourth level</a:t>
             </a:r>
           </a:p>
           <a:p>
             <a:pPr lvl="4"/>
             <a:r>
-              <a:rPr lang="en-US"/>
+              <a:rPr lang="en-US" smtClean="0"/>
               <a:t>Fifth level</a:t>
             </a:r>
+            <a:endParaRPr lang="en-US"/>
           </a:p>
         </p:txBody>
       </p:sp>
@@ -1352,7 +1354,7 @@
           <a:p>
             <a:fld id="{5BCAD085-E8A6-8845-BD4E-CB4CCA059FC4}" type="datetimeFigureOut">
               <a:rPr lang="en-US" smtClean="0"/>
-              <a:t>6/8/2026</a:t>
+              <a:t>1/27/13</a:t>
             </a:fld>
             <a:endParaRPr lang="en-US"/>
           </a:p>
@@ -1450,9 +1452,10 @@
           </a:lstStyle>
           <a:p>
             <a:r>
-              <a:rPr lang="en-US"/>
+              <a:rPr lang="en-US" smtClean="0"/>
               <a:t>Click to edit Master title style</a:t>
             </a:r>
+            <a:endParaRPr lang="en-US"/>
           </a:p>
         </p:txBody>
       </p:sp>
@@ -1515,7 +1518,7 @@
           <a:p>
             <a:pPr lvl="0"/>
             <a:r>
-              <a:rPr lang="en-US"/>
+              <a:rPr lang="en-US" smtClean="0"/>
               <a:t>Click to edit Master text styles</a:t>
             </a:r>
           </a:p>
@@ -1571,37 +1574,38 @@
           <a:p>
             <a:pPr lvl="0"/>
             <a:r>
-              <a:rPr lang="en-US"/>
+              <a:rPr lang="en-US" smtClean="0"/>
               <a:t>Click to edit Master text styles</a:t>
             </a:r>
           </a:p>
           <a:p>
             <a:pPr lvl="1"/>
             <a:r>
-              <a:rPr lang="en-US"/>
+              <a:rPr lang="en-US" smtClean="0"/>
               <a:t>Second level</a:t>
             </a:r>
           </a:p>
           <a:p>
             <a:pPr lvl="2"/>
             <a:r>
-              <a:rPr lang="en-US"/>
+              <a:rPr lang="en-US" smtClean="0"/>
               <a:t>Third level</a:t>
             </a:r>
           </a:p>
           <a:p>
             <a:pPr lvl="3"/>
             <a:r>
-              <a:rPr lang="en-US"/>
+              <a:rPr lang="en-US" smtClean="0"/>
               <a:t>Fourth level</a:t>
             </a:r>
           </a:p>
           <a:p>
             <a:pPr lvl="4"/>
             <a:r>
-              <a:rPr lang="en-US"/>
+              <a:rPr lang="en-US" smtClean="0"/>
               <a:t>Fifth level</a:t>
             </a:r>
+            <a:endParaRPr lang="en-US"/>
           </a:p>
         </p:txBody>
       </p:sp>
@@ -1664,7 +1668,7 @@
           <a:p>
             <a:pPr lvl="0"/>
             <a:r>
-              <a:rPr lang="en-US"/>
+              <a:rPr lang="en-US" smtClean="0"/>
               <a:t>Click to edit Master text styles</a:t>
             </a:r>
           </a:p>
@@ -1720,37 +1724,38 @@
           <a:p>
             <a:pPr lvl="0"/>
             <a:r>
-              <a:rPr lang="en-US"/>
+              <a:rPr lang="en-US" smtClean="0"/>
               <a:t>Click to edit Master text styles</a:t>
             </a:r>
           </a:p>
           <a:p>
             <a:pPr lvl="1"/>
             <a:r>
-              <a:rPr lang="en-US"/>
+              <a:rPr lang="en-US" smtClean="0"/>
               <a:t>Second level</a:t>
             </a:r>
           </a:p>
           <a:p>
             <a:pPr lvl="2"/>
             <a:r>
-              <a:rPr lang="en-US"/>
+              <a:rPr lang="en-US" smtClean="0"/>
               <a:t>Third level</a:t>
             </a:r>
           </a:p>
           <a:p>
             <a:pPr lvl="3"/>
             <a:r>
-              <a:rPr lang="en-US"/>
+              <a:rPr lang="en-US" smtClean="0"/>
               <a:t>Fourth level</a:t>
             </a:r>
           </a:p>
           <a:p>
             <a:pPr lvl="4"/>
             <a:r>
-              <a:rPr lang="en-US"/>
+              <a:rPr lang="en-US" smtClean="0"/>
               <a:t>Fifth level</a:t>
             </a:r>
+            <a:endParaRPr lang="en-US"/>
           </a:p>
         </p:txBody>
       </p:sp>
@@ -1771,7 +1776,7 @@
           <a:p>
             <a:fld id="{5BCAD085-E8A6-8845-BD4E-CB4CCA059FC4}" type="datetimeFigureOut">
               <a:rPr lang="en-US" smtClean="0"/>
-              <a:t>6/8/2026</a:t>
+              <a:t>1/27/13</a:t>
             </a:fld>
             <a:endParaRPr lang="en-US"/>
           </a:p>
@@ -1865,9 +1870,10 @@
           <a:lstStyle/>
           <a:p>
             <a:r>
-              <a:rPr lang="en-US"/>
+              <a:rPr lang="en-US" smtClean="0"/>
               <a:t>Click to edit Master title style</a:t>
             </a:r>
+            <a:endParaRPr lang="en-US"/>
           </a:p>
         </p:txBody>
       </p:sp>
@@ -1888,7 +1894,7 @@
           <a:p>
             <a:fld id="{5BCAD085-E8A6-8845-BD4E-CB4CCA059FC4}" type="datetimeFigureOut">
               <a:rPr lang="en-US" smtClean="0"/>
-              <a:t>6/8/2026</a:t>
+              <a:t>1/27/13</a:t>
             </a:fld>
             <a:endParaRPr lang="en-US"/>
           </a:p>
@@ -1983,7 +1989,7 @@
           <a:p>
             <a:fld id="{5BCAD085-E8A6-8845-BD4E-CB4CCA059FC4}" type="datetimeFigureOut">
               <a:rPr lang="en-US" smtClean="0"/>
-              <a:t>6/8/2026</a:t>
+              <a:t>1/27/13</a:t>
             </a:fld>
             <a:endParaRPr lang="en-US"/>
           </a:p>
@@ -2086,9 +2092,10 @@
           </a:lstStyle>
           <a:p>
             <a:r>
-              <a:rPr lang="en-US"/>
+              <a:rPr lang="en-US" smtClean="0"/>
               <a:t>Click to edit Master title style</a:t>
             </a:r>
+            <a:endParaRPr lang="en-US"/>
           </a:p>
         </p:txBody>
       </p:sp>
@@ -2142,37 +2149,38 @@
           <a:p>
             <a:pPr lvl="0"/>
             <a:r>
-              <a:rPr lang="en-US"/>
+              <a:rPr lang="en-US" smtClean="0"/>
               <a:t>Click to edit Master text styles</a:t>
             </a:r>
           </a:p>
           <a:p>
             <a:pPr lvl="1"/>
             <a:r>
-              <a:rPr lang="en-US"/>
+              <a:rPr lang="en-US" smtClean="0"/>
               <a:t>Second level</a:t>
             </a:r>
           </a:p>
           <a:p>
             <a:pPr lvl="2"/>
             <a:r>
-              <a:rPr lang="en-US"/>
+              <a:rPr lang="en-US" smtClean="0"/>
               <a:t>Third level</a:t>
             </a:r>
           </a:p>
           <a:p>
             <a:pPr lvl="3"/>
             <a:r>
-              <a:rPr lang="en-US"/>
+              <a:rPr lang="en-US" smtClean="0"/>
               <a:t>Fourth level</a:t>
             </a:r>
           </a:p>
           <a:p>
             <a:pPr lvl="4"/>
             <a:r>
-              <a:rPr lang="en-US"/>
+              <a:rPr lang="en-US" smtClean="0"/>
               <a:t>Fifth level</a:t>
             </a:r>
+            <a:endParaRPr lang="en-US"/>
           </a:p>
         </p:txBody>
       </p:sp>
@@ -2235,7 +2243,7 @@
           <a:p>
             <a:pPr lvl="0"/>
             <a:r>
-              <a:rPr lang="en-US"/>
+              <a:rPr lang="en-US" smtClean="0"/>
               <a:t>Click to edit Master text styles</a:t>
             </a:r>
           </a:p>
@@ -2258,7 +2266,7 @@
           <a:p>
             <a:fld id="{5BCAD085-E8A6-8845-BD4E-CB4CCA059FC4}" type="datetimeFigureOut">
               <a:rPr lang="en-US" smtClean="0"/>
-              <a:t>6/8/2026</a:t>
+              <a:t>1/27/13</a:t>
             </a:fld>
             <a:endParaRPr lang="en-US"/>
           </a:p>
@@ -2361,9 +2369,10 @@
           </a:lstStyle>
           <a:p>
             <a:r>
-              <a:rPr lang="en-US"/>
+              <a:rPr lang="en-US" smtClean="0"/>
               <a:t>Click to edit Master title style</a:t>
             </a:r>
+            <a:endParaRPr lang="en-US"/>
           </a:p>
         </p:txBody>
       </p:sp>
@@ -2487,7 +2496,7 @@
           <a:p>
             <a:pPr lvl="0"/>
             <a:r>
-              <a:rPr lang="en-US"/>
+              <a:rPr lang="en-US" smtClean="0"/>
               <a:t>Click to edit Master text styles</a:t>
             </a:r>
           </a:p>
@@ -2510,7 +2519,7 @@
           <a:p>
             <a:fld id="{5BCAD085-E8A6-8845-BD4E-CB4CCA059FC4}" type="datetimeFigureOut">
               <a:rPr lang="en-US" smtClean="0"/>
-              <a:t>6/8/2026</a:t>
+              <a:t>1/27/13</a:t>
             </a:fld>
             <a:endParaRPr lang="en-US"/>
           </a:p>
@@ -2619,9 +2628,10 @@
           <a:lstStyle/>
           <a:p>
             <a:r>
-              <a:rPr lang="en-US"/>
+              <a:rPr lang="en-US" smtClean="0"/>
               <a:t>Click to edit Master title style</a:t>
             </a:r>
+            <a:endParaRPr lang="en-US"/>
           </a:p>
         </p:txBody>
       </p:sp>
@@ -2652,37 +2662,38 @@
           <a:p>
             <a:pPr lvl="0"/>
             <a:r>
-              <a:rPr lang="en-US"/>
+              <a:rPr lang="en-US" smtClean="0"/>
               <a:t>Click to edit Master text styles</a:t>
             </a:r>
           </a:p>
           <a:p>
             <a:pPr lvl="1"/>
             <a:r>
-              <a:rPr lang="en-US"/>
+              <a:rPr lang="en-US" smtClean="0"/>
               <a:t>Second level</a:t>
             </a:r>
           </a:p>
           <a:p>
             <a:pPr lvl="2"/>
             <a:r>
-              <a:rPr lang="en-US"/>
+              <a:rPr lang="en-US" smtClean="0"/>
               <a:t>Third level</a:t>
             </a:r>
           </a:p>
           <a:p>
             <a:pPr lvl="3"/>
             <a:r>
-              <a:rPr lang="en-US"/>
+              <a:rPr lang="en-US" smtClean="0"/>
               <a:t>Fourth level</a:t>
             </a:r>
           </a:p>
           <a:p>
             <a:pPr lvl="4"/>
             <a:r>
-              <a:rPr lang="en-US"/>
+              <a:rPr lang="en-US" smtClean="0"/>
               <a:t>Fifth level</a:t>
             </a:r>
+            <a:endParaRPr lang="en-US"/>
           </a:p>
         </p:txBody>
       </p:sp>
@@ -2721,7 +2732,7 @@
           <a:p>
             <a:fld id="{5BCAD085-E8A6-8845-BD4E-CB4CCA059FC4}" type="datetimeFigureOut">
               <a:rPr lang="en-US" smtClean="0"/>
-              <a:t>6/8/2026</a:t>
+              <a:t>1/27/13</a:t>
             </a:fld>
             <a:endParaRPr lang="en-US"/>
           </a:p>
@@ -3080,7 +3091,7 @@
 </file>
 
 <file path=ppt/slides/slide1.xml><?xml version="1.0" encoding="utf-8"?>
-<p:sld xmlns:a="http://schemas.openxmlformats.org/drawingml/2006/main" xmlns:r="http://schemas.openxmlformats.org/officeDocument/2006/relationships" xmlns:p="http://schemas.openxmlformats.org/presentationml/2006/main">
+<p:sld xmlns:a="http://schemas.openxmlformats.org/drawingml/2006/main" xmlns:p="http://schemas.openxmlformats.org/presentationml/2006/main" xmlns:r="http://schemas.openxmlformats.org/officeDocument/2006/relationships">
   <p:cSld>
     <p:spTree>
       <p:nvGrpSpPr>
@@ -3088,14 +3099,7 @@
         <p:cNvGrpSpPr/>
         <p:nvPr/>
       </p:nvGrpSpPr>
-      <p:grpSpPr>
-        <a:xfrm>
-          <a:off x="0" y="0"/>
-          <a:ext cx="0" cy="0"/>
-          <a:chOff x="0" y="0"/>
-          <a:chExt cx="0" cy="0"/>
-        </a:xfrm>
-      </p:grpSpPr>
+      <p:grpSpPr/>
       <p:pic>
         <p:nvPicPr>
           <p:cNvPr id="2" name="Picture 1" descr="slide-001.png"/>
@@ -3160,7 +3164,6 @@
           <a:lstStyle/>
           <a:p>
             <a:pPr algn="ctr"/>
-            <a:endParaRPr/>
           </a:p>
         </p:txBody>
       </p:sp>
@@ -3204,7 +3207,6 @@
           <a:lstStyle/>
           <a:p>
             <a:pPr algn="ctr"/>
-            <a:endParaRPr/>
           </a:p>
         </p:txBody>
       </p:sp>
@@ -3248,7 +3250,6 @@
           <a:lstStyle/>
           <a:p>
             <a:pPr algn="ctr"/>
-            <a:endParaRPr/>
           </a:p>
         </p:txBody>
       </p:sp>
@@ -3292,7 +3293,6 @@
           <a:lstStyle/>
           <a:p>
             <a:pPr algn="ctr"/>
-            <a:endParaRPr/>
           </a:p>
         </p:txBody>
       </p:sp>
@@ -3336,10 +3336,693 @@
           <a:lstStyle/>
           <a:p>
             <a:pPr algn="ctr"/>
-            <a:endParaRPr/>
-          </a:p>
-        </p:txBody>
-      </p:sp>
+          </a:p>
+        </p:txBody>
+      </p:sp>
+      <p:sp>
+        <p:nvSpPr>
+          <p:cNvPr id="8" name="Rectangle 7">
+            <a:hlinkClick r:id="rId8"/>
+          </p:cNvPr>
+          <p:cNvSpPr/>
+          <p:nvPr/>
+        </p:nvSpPr>
+        <p:spPr>
+          <a:xfrm>
+            <a:off x="10360152" y="3570732"/>
+            <a:ext cx="1143000" cy="182880"/>
+          </a:xfrm>
+          <a:prstGeom prst="rect">
+            <a:avLst/>
+          </a:prstGeom>
+          <a:noFill/>
+          <a:ln>
+            <a:noFill/>
+          </a:ln>
+        </p:spPr>
+        <p:style>
+          <a:lnRef idx="1">
+            <a:schemeClr val="accent1"/>
+          </a:lnRef>
+          <a:fillRef idx="3">
+            <a:schemeClr val="accent1"/>
+          </a:fillRef>
+          <a:effectRef idx="2">
+            <a:schemeClr val="accent1"/>
+          </a:effectRef>
+          <a:fontRef idx="minor">
+            <a:schemeClr val="lt1"/>
+          </a:fontRef>
+        </p:style>
+        <p:txBody>
+          <a:bodyPr rtlCol="0" anchor="ctr"/>
+          <a:lstStyle/>
+          <a:p>
+            <a:pPr algn="ctr"/>
+          </a:p>
+        </p:txBody>
+      </p:sp>
+      <p:sp>
+        <p:nvSpPr>
+          <p:cNvPr id="9" name="Rectangle 8">
+            <a:hlinkClick r:id="rId9"/>
+          </p:cNvPr>
+          <p:cNvSpPr/>
+          <p:nvPr/>
+        </p:nvSpPr>
+        <p:spPr>
+          <a:xfrm>
+            <a:off x="10360152" y="3776472"/>
+            <a:ext cx="1143000" cy="182880"/>
+          </a:xfrm>
+          <a:prstGeom prst="rect">
+            <a:avLst/>
+          </a:prstGeom>
+          <a:noFill/>
+          <a:ln>
+            <a:noFill/>
+          </a:ln>
+        </p:spPr>
+        <p:style>
+          <a:lnRef idx="1">
+            <a:schemeClr val="accent1"/>
+          </a:lnRef>
+          <a:fillRef idx="3">
+            <a:schemeClr val="accent1"/>
+          </a:fillRef>
+          <a:effectRef idx="2">
+            <a:schemeClr val="accent1"/>
+          </a:effectRef>
+          <a:fontRef idx="minor">
+            <a:schemeClr val="lt1"/>
+          </a:fontRef>
+        </p:style>
+        <p:txBody>
+          <a:bodyPr rtlCol="0" anchor="ctr"/>
+          <a:lstStyle/>
+          <a:p>
+            <a:pPr algn="ctr"/>
+          </a:p>
+        </p:txBody>
+      </p:sp>
+      <p:sp>
+        <p:nvSpPr>
+          <p:cNvPr id="10" name="Rectangle 9">
+            <a:hlinkClick r:id="rId10"/>
+          </p:cNvPr>
+          <p:cNvSpPr/>
+          <p:nvPr/>
+        </p:nvSpPr>
+        <p:spPr>
+          <a:xfrm>
+            <a:off x="10360152" y="3982211"/>
+            <a:ext cx="1143000" cy="182880"/>
+          </a:xfrm>
+          <a:prstGeom prst="rect">
+            <a:avLst/>
+          </a:prstGeom>
+          <a:noFill/>
+          <a:ln>
+            <a:noFill/>
+          </a:ln>
+        </p:spPr>
+        <p:style>
+          <a:lnRef idx="1">
+            <a:schemeClr val="accent1"/>
+          </a:lnRef>
+          <a:fillRef idx="3">
+            <a:schemeClr val="accent1"/>
+          </a:fillRef>
+          <a:effectRef idx="2">
+            <a:schemeClr val="accent1"/>
+          </a:effectRef>
+          <a:fontRef idx="minor">
+            <a:schemeClr val="lt1"/>
+          </a:fontRef>
+        </p:style>
+        <p:txBody>
+          <a:bodyPr rtlCol="0" anchor="ctr"/>
+          <a:lstStyle/>
+          <a:p>
+            <a:pPr algn="ctr"/>
+          </a:p>
+        </p:txBody>
+      </p:sp>
+      <p:sp>
+        <p:nvSpPr>
+          <p:cNvPr id="11" name="Rectangle 10">
+            <a:hlinkClick r:id="rId11"/>
+          </p:cNvPr>
+          <p:cNvSpPr/>
+          <p:nvPr/>
+        </p:nvSpPr>
+        <p:spPr>
+          <a:xfrm>
+            <a:off x="10360152" y="4187952"/>
+            <a:ext cx="1143000" cy="182880"/>
+          </a:xfrm>
+          <a:prstGeom prst="rect">
+            <a:avLst/>
+          </a:prstGeom>
+          <a:noFill/>
+          <a:ln>
+            <a:noFill/>
+          </a:ln>
+        </p:spPr>
+        <p:style>
+          <a:lnRef idx="1">
+            <a:schemeClr val="accent1"/>
+          </a:lnRef>
+          <a:fillRef idx="3">
+            <a:schemeClr val="accent1"/>
+          </a:fillRef>
+          <a:effectRef idx="2">
+            <a:schemeClr val="accent1"/>
+          </a:effectRef>
+          <a:fontRef idx="minor">
+            <a:schemeClr val="lt1"/>
+          </a:fontRef>
+        </p:style>
+        <p:txBody>
+          <a:bodyPr rtlCol="0" anchor="ctr"/>
+          <a:lstStyle/>
+          <a:p>
+            <a:pPr algn="ctr"/>
+          </a:p>
+        </p:txBody>
+      </p:sp>
+      <p:sp>
+        <p:nvSpPr>
+          <p:cNvPr id="12" name="Rectangle 11">
+            <a:hlinkClick r:id="rId12"/>
+          </p:cNvPr>
+          <p:cNvSpPr/>
+          <p:nvPr/>
+        </p:nvSpPr>
+        <p:spPr>
+          <a:xfrm>
+            <a:off x="10360152" y="4393692"/>
+            <a:ext cx="1143000" cy="182880"/>
+          </a:xfrm>
+          <a:prstGeom prst="rect">
+            <a:avLst/>
+          </a:prstGeom>
+          <a:noFill/>
+          <a:ln>
+            <a:noFill/>
+          </a:ln>
+        </p:spPr>
+        <p:style>
+          <a:lnRef idx="1">
+            <a:schemeClr val="accent1"/>
+          </a:lnRef>
+          <a:fillRef idx="3">
+            <a:schemeClr val="accent1"/>
+          </a:fillRef>
+          <a:effectRef idx="2">
+            <a:schemeClr val="accent1"/>
+          </a:effectRef>
+          <a:fontRef idx="minor">
+            <a:schemeClr val="lt1"/>
+          </a:fontRef>
+        </p:style>
+        <p:txBody>
+          <a:bodyPr rtlCol="0" anchor="ctr"/>
+          <a:lstStyle/>
+          <a:p>
+            <a:pPr algn="ctr"/>
+          </a:p>
+        </p:txBody>
+      </p:sp>
+      <p:sp>
+        <p:nvSpPr>
+          <p:cNvPr id="13" name="Rectangle 12">
+            <a:hlinkClick r:id="rId13"/>
+          </p:cNvPr>
+          <p:cNvSpPr/>
+          <p:nvPr/>
+        </p:nvSpPr>
+        <p:spPr>
+          <a:xfrm>
+            <a:off x="10360152" y="4599431"/>
+            <a:ext cx="1143000" cy="182880"/>
+          </a:xfrm>
+          <a:prstGeom prst="rect">
+            <a:avLst/>
+          </a:prstGeom>
+          <a:noFill/>
+          <a:ln>
+            <a:noFill/>
+          </a:ln>
+        </p:spPr>
+        <p:style>
+          <a:lnRef idx="1">
+            <a:schemeClr val="accent1"/>
+          </a:lnRef>
+          <a:fillRef idx="3">
+            <a:schemeClr val="accent1"/>
+          </a:fillRef>
+          <a:effectRef idx="2">
+            <a:schemeClr val="accent1"/>
+          </a:effectRef>
+          <a:fontRef idx="minor">
+            <a:schemeClr val="lt1"/>
+          </a:fontRef>
+        </p:style>
+        <p:txBody>
+          <a:bodyPr rtlCol="0" anchor="ctr"/>
+          <a:lstStyle/>
+          <a:p>
+            <a:pPr algn="ctr"/>
+          </a:p>
+        </p:txBody>
+      </p:sp>
+    </p:spTree>
+  </p:cSld>
+  <p:clrMapOvr>
+    <a:masterClrMapping/>
+  </p:clrMapOvr>
+</p:sld>
+</file>
+
+<file path=ppt/slides/slide10.xml><?xml version="1.0" encoding="utf-8"?>
+<p:sld xmlns:a="http://schemas.openxmlformats.org/drawingml/2006/main" xmlns:p="http://schemas.openxmlformats.org/presentationml/2006/main" xmlns:r="http://schemas.openxmlformats.org/officeDocument/2006/relationships">
+  <p:cSld>
+    <p:spTree>
+      <p:nvGrpSpPr>
+        <p:cNvPr id="1" name=""/>
+        <p:cNvGrpSpPr/>
+        <p:nvPr/>
+      </p:nvGrpSpPr>
+      <p:grpSpPr/>
+      <p:pic>
+        <p:nvPicPr>
+          <p:cNvPr id="2" name="Picture 1" descr="slide-010.png"/>
+          <p:cNvPicPr>
+            <a:picLocks noChangeAspect="1"/>
+          </p:cNvPicPr>
+          <p:nvPr/>
+        </p:nvPicPr>
+        <p:blipFill>
+          <a:blip r:embed="rId2"/>
+          <a:stretch>
+            <a:fillRect/>
+          </a:stretch>
+        </p:blipFill>
+        <p:spPr>
+          <a:xfrm>
+            <a:off x="0" y="0"/>
+            <a:ext cx="12191999" cy="6858000"/>
+          </a:xfrm>
+          <a:prstGeom prst="rect">
+            <a:avLst/>
+          </a:prstGeom>
+        </p:spPr>
+      </p:pic>
+      <p:sp>
+        <p:nvSpPr>
+          <p:cNvPr id="3" name="Rectangle 2">
+            <a:hlinkClick r:id="rId3"/>
+          </p:cNvPr>
+          <p:cNvSpPr/>
+          <p:nvPr/>
+        </p:nvSpPr>
+        <p:spPr>
+          <a:xfrm>
+            <a:off x="9509760" y="384048"/>
+            <a:ext cx="1828800" cy="310896"/>
+          </a:xfrm>
+          <a:prstGeom prst="rect">
+            <a:avLst/>
+          </a:prstGeom>
+          <a:noFill/>
+          <a:ln>
+            <a:noFill/>
+          </a:ln>
+        </p:spPr>
+        <p:style>
+          <a:lnRef idx="1">
+            <a:schemeClr val="accent1"/>
+          </a:lnRef>
+          <a:fillRef idx="3">
+            <a:schemeClr val="accent1"/>
+          </a:fillRef>
+          <a:effectRef idx="2">
+            <a:schemeClr val="accent1"/>
+          </a:effectRef>
+          <a:fontRef idx="minor">
+            <a:schemeClr val="lt1"/>
+          </a:fontRef>
+        </p:style>
+        <p:txBody>
+          <a:bodyPr rtlCol="0" anchor="ctr"/>
+          <a:lstStyle/>
+          <a:p>
+            <a:pPr algn="ctr"/>
+          </a:p>
+        </p:txBody>
+      </p:sp>
+      <p:sp>
+        <p:nvSpPr>
+          <p:cNvPr id="4" name="Rectangle 3">
+            <a:hlinkClick r:id="rId3"/>
+          </p:cNvPr>
+          <p:cNvSpPr/>
+          <p:nvPr/>
+        </p:nvSpPr>
+        <p:spPr>
+          <a:xfrm>
+            <a:off x="6400800" y="6473952"/>
+            <a:ext cx="4937760" cy="201168"/>
+          </a:xfrm>
+          <a:prstGeom prst="rect">
+            <a:avLst/>
+          </a:prstGeom>
+          <a:noFill/>
+          <a:ln>
+            <a:noFill/>
+          </a:ln>
+        </p:spPr>
+        <p:style>
+          <a:lnRef idx="1">
+            <a:schemeClr val="accent1"/>
+          </a:lnRef>
+          <a:fillRef idx="3">
+            <a:schemeClr val="accent1"/>
+          </a:fillRef>
+          <a:effectRef idx="2">
+            <a:schemeClr val="accent1"/>
+          </a:effectRef>
+          <a:fontRef idx="minor">
+            <a:schemeClr val="lt1"/>
+          </a:fontRef>
+        </p:style>
+        <p:txBody>
+          <a:bodyPr rtlCol="0" anchor="ctr"/>
+          <a:lstStyle/>
+          <a:p>
+            <a:pPr algn="ctr"/>
+          </a:p>
+        </p:txBody>
+      </p:sp>
+    </p:spTree>
+  </p:cSld>
+  <p:clrMapOvr>
+    <a:masterClrMapping/>
+  </p:clrMapOvr>
+</p:sld>
+</file>
+
+<file path=ppt/slides/slide11.xml><?xml version="1.0" encoding="utf-8"?>
+<p:sld xmlns:a="http://schemas.openxmlformats.org/drawingml/2006/main" xmlns:p="http://schemas.openxmlformats.org/presentationml/2006/main" xmlns:r="http://schemas.openxmlformats.org/officeDocument/2006/relationships">
+  <p:cSld>
+    <p:spTree>
+      <p:nvGrpSpPr>
+        <p:cNvPr id="1" name=""/>
+        <p:cNvGrpSpPr/>
+        <p:nvPr/>
+      </p:nvGrpSpPr>
+      <p:grpSpPr/>
+      <p:pic>
+        <p:nvPicPr>
+          <p:cNvPr id="2" name="Picture 1" descr="slide-011.png"/>
+          <p:cNvPicPr>
+            <a:picLocks noChangeAspect="1"/>
+          </p:cNvPicPr>
+          <p:nvPr/>
+        </p:nvPicPr>
+        <p:blipFill>
+          <a:blip r:embed="rId2"/>
+          <a:stretch>
+            <a:fillRect/>
+          </a:stretch>
+        </p:blipFill>
+        <p:spPr>
+          <a:xfrm>
+            <a:off x="0" y="0"/>
+            <a:ext cx="12191999" cy="6858000"/>
+          </a:xfrm>
+          <a:prstGeom prst="rect">
+            <a:avLst/>
+          </a:prstGeom>
+        </p:spPr>
+      </p:pic>
+      <p:sp>
+        <p:nvSpPr>
+          <p:cNvPr id="3" name="Rectangle 2">
+            <a:hlinkClick r:id="rId3"/>
+          </p:cNvPr>
+          <p:cNvSpPr/>
+          <p:nvPr/>
+        </p:nvSpPr>
+        <p:spPr>
+          <a:xfrm>
+            <a:off x="9509760" y="384048"/>
+            <a:ext cx="1828800" cy="310896"/>
+          </a:xfrm>
+          <a:prstGeom prst="rect">
+            <a:avLst/>
+          </a:prstGeom>
+          <a:noFill/>
+          <a:ln>
+            <a:noFill/>
+          </a:ln>
+        </p:spPr>
+        <p:style>
+          <a:lnRef idx="1">
+            <a:schemeClr val="accent1"/>
+          </a:lnRef>
+          <a:fillRef idx="3">
+            <a:schemeClr val="accent1"/>
+          </a:fillRef>
+          <a:effectRef idx="2">
+            <a:schemeClr val="accent1"/>
+          </a:effectRef>
+          <a:fontRef idx="minor">
+            <a:schemeClr val="lt1"/>
+          </a:fontRef>
+        </p:style>
+        <p:txBody>
+          <a:bodyPr rtlCol="0" anchor="ctr"/>
+          <a:lstStyle/>
+          <a:p>
+            <a:pPr algn="ctr"/>
+          </a:p>
+        </p:txBody>
+      </p:sp>
+      <p:sp>
+        <p:nvSpPr>
+          <p:cNvPr id="4" name="Rectangle 3">
+            <a:hlinkClick r:id="rId3"/>
+          </p:cNvPr>
+          <p:cNvSpPr/>
+          <p:nvPr/>
+        </p:nvSpPr>
+        <p:spPr>
+          <a:xfrm>
+            <a:off x="6400800" y="6473952"/>
+            <a:ext cx="4937760" cy="201168"/>
+          </a:xfrm>
+          <a:prstGeom prst="rect">
+            <a:avLst/>
+          </a:prstGeom>
+          <a:noFill/>
+          <a:ln>
+            <a:noFill/>
+          </a:ln>
+        </p:spPr>
+        <p:style>
+          <a:lnRef idx="1">
+            <a:schemeClr val="accent1"/>
+          </a:lnRef>
+          <a:fillRef idx="3">
+            <a:schemeClr val="accent1"/>
+          </a:fillRef>
+          <a:effectRef idx="2">
+            <a:schemeClr val="accent1"/>
+          </a:effectRef>
+          <a:fontRef idx="minor">
+            <a:schemeClr val="lt1"/>
+          </a:fontRef>
+        </p:style>
+        <p:txBody>
+          <a:bodyPr rtlCol="0" anchor="ctr"/>
+          <a:lstStyle/>
+          <a:p>
+            <a:pPr algn="ctr"/>
+          </a:p>
+        </p:txBody>
+      </p:sp>
+    </p:spTree>
+  </p:cSld>
+  <p:clrMapOvr>
+    <a:masterClrMapping/>
+  </p:clrMapOvr>
+</p:sld>
+</file>
+
+<file path=ppt/slides/slide12.xml><?xml version="1.0" encoding="utf-8"?>
+<p:sld xmlns:a="http://schemas.openxmlformats.org/drawingml/2006/main" xmlns:p="http://schemas.openxmlformats.org/presentationml/2006/main" xmlns:r="http://schemas.openxmlformats.org/officeDocument/2006/relationships">
+  <p:cSld>
+    <p:spTree>
+      <p:nvGrpSpPr>
+        <p:cNvPr id="1" name=""/>
+        <p:cNvGrpSpPr/>
+        <p:nvPr/>
+      </p:nvGrpSpPr>
+      <p:grpSpPr/>
+      <p:pic>
+        <p:nvPicPr>
+          <p:cNvPr id="2" name="Picture 1" descr="slide-012.png"/>
+          <p:cNvPicPr>
+            <a:picLocks noChangeAspect="1"/>
+          </p:cNvPicPr>
+          <p:nvPr/>
+        </p:nvPicPr>
+        <p:blipFill>
+          <a:blip r:embed="rId2"/>
+          <a:stretch>
+            <a:fillRect/>
+          </a:stretch>
+        </p:blipFill>
+        <p:spPr>
+          <a:xfrm>
+            <a:off x="0" y="0"/>
+            <a:ext cx="12191999" cy="6858000"/>
+          </a:xfrm>
+          <a:prstGeom prst="rect">
+            <a:avLst/>
+          </a:prstGeom>
+        </p:spPr>
+      </p:pic>
+      <p:sp>
+        <p:nvSpPr>
+          <p:cNvPr id="3" name="Rectangle 2">
+            <a:hlinkClick r:id="rId3"/>
+          </p:cNvPr>
+          <p:cNvSpPr/>
+          <p:nvPr/>
+        </p:nvSpPr>
+        <p:spPr>
+          <a:xfrm>
+            <a:off x="9509760" y="384048"/>
+            <a:ext cx="1828800" cy="310896"/>
+          </a:xfrm>
+          <a:prstGeom prst="rect">
+            <a:avLst/>
+          </a:prstGeom>
+          <a:noFill/>
+          <a:ln>
+            <a:noFill/>
+          </a:ln>
+        </p:spPr>
+        <p:style>
+          <a:lnRef idx="1">
+            <a:schemeClr val="accent1"/>
+          </a:lnRef>
+          <a:fillRef idx="3">
+            <a:schemeClr val="accent1"/>
+          </a:fillRef>
+          <a:effectRef idx="2">
+            <a:schemeClr val="accent1"/>
+          </a:effectRef>
+          <a:fontRef idx="minor">
+            <a:schemeClr val="lt1"/>
+          </a:fontRef>
+        </p:style>
+        <p:txBody>
+          <a:bodyPr rtlCol="0" anchor="ctr"/>
+          <a:lstStyle/>
+          <a:p>
+            <a:pPr algn="ctr"/>
+          </a:p>
+        </p:txBody>
+      </p:sp>
+      <p:sp>
+        <p:nvSpPr>
+          <p:cNvPr id="4" name="Rectangle 3">
+            <a:hlinkClick r:id="rId3"/>
+          </p:cNvPr>
+          <p:cNvSpPr/>
+          <p:nvPr/>
+        </p:nvSpPr>
+        <p:spPr>
+          <a:xfrm>
+            <a:off x="6400800" y="6473952"/>
+            <a:ext cx="4937760" cy="201168"/>
+          </a:xfrm>
+          <a:prstGeom prst="rect">
+            <a:avLst/>
+          </a:prstGeom>
+          <a:noFill/>
+          <a:ln>
+            <a:noFill/>
+          </a:ln>
+        </p:spPr>
+        <p:style>
+          <a:lnRef idx="1">
+            <a:schemeClr val="accent1"/>
+          </a:lnRef>
+          <a:fillRef idx="3">
+            <a:schemeClr val="accent1"/>
+          </a:fillRef>
+          <a:effectRef idx="2">
+            <a:schemeClr val="accent1"/>
+          </a:effectRef>
+          <a:fontRef idx="minor">
+            <a:schemeClr val="lt1"/>
+          </a:fontRef>
+        </p:style>
+        <p:txBody>
+          <a:bodyPr rtlCol="0" anchor="ctr"/>
+          <a:lstStyle/>
+          <a:p>
+            <a:pPr algn="ctr"/>
+          </a:p>
+        </p:txBody>
+      </p:sp>
+    </p:spTree>
+  </p:cSld>
+  <p:clrMapOvr>
+    <a:masterClrMapping/>
+  </p:clrMapOvr>
+</p:sld>
+</file>
+
+<file path=ppt/slides/slide13.xml><?xml version="1.0" encoding="utf-8"?>
+<p:sld xmlns:a="http://schemas.openxmlformats.org/drawingml/2006/main" xmlns:p="http://schemas.openxmlformats.org/presentationml/2006/main" xmlns:r="http://schemas.openxmlformats.org/officeDocument/2006/relationships">
+  <p:cSld>
+    <p:spTree>
+      <p:nvGrpSpPr>
+        <p:cNvPr id="1" name=""/>
+        <p:cNvGrpSpPr/>
+        <p:nvPr/>
+      </p:nvGrpSpPr>
+      <p:grpSpPr/>
+      <p:pic>
+        <p:nvPicPr>
+          <p:cNvPr id="2" name="Picture 1" descr="slide-013.png"/>
+          <p:cNvPicPr>
+            <a:picLocks noChangeAspect="1"/>
+          </p:cNvPicPr>
+          <p:nvPr/>
+        </p:nvPicPr>
+        <p:blipFill>
+          <a:blip r:embed="rId2"/>
+          <a:stretch>
+            <a:fillRect/>
+          </a:stretch>
+        </p:blipFill>
+        <p:spPr>
+          <a:xfrm>
+            <a:off x="0" y="0"/>
+            <a:ext cx="12191999" cy="6858000"/>
+          </a:xfrm>
+          <a:prstGeom prst="rect">
+            <a:avLst/>
+          </a:prstGeom>
+        </p:spPr>
+      </p:pic>
     </p:spTree>
   </p:cSld>
   <p:clrMapOvr>
@@ -3349,7 +4032,7 @@
 </file>
 
 <file path=ppt/slides/slide2.xml><?xml version="1.0" encoding="utf-8"?>
-<p:sld xmlns:a="http://schemas.openxmlformats.org/drawingml/2006/main" xmlns:r="http://schemas.openxmlformats.org/officeDocument/2006/relationships" xmlns:p="http://schemas.openxmlformats.org/presentationml/2006/main">
+<p:sld xmlns:a="http://schemas.openxmlformats.org/drawingml/2006/main" xmlns:p="http://schemas.openxmlformats.org/presentationml/2006/main" xmlns:r="http://schemas.openxmlformats.org/officeDocument/2006/relationships">
   <p:cSld>
     <p:spTree>
       <p:nvGrpSpPr>
@@ -3357,14 +4040,7 @@
         <p:cNvGrpSpPr/>
         <p:nvPr/>
       </p:nvGrpSpPr>
-      <p:grpSpPr>
-        <a:xfrm>
-          <a:off x="0" y="0"/>
-          <a:ext cx="0" cy="0"/>
-          <a:chOff x="0" y="0"/>
-          <a:chExt cx="0" cy="0"/>
-        </a:xfrm>
-      </p:grpSpPr>
+      <p:grpSpPr/>
       <p:pic>
         <p:nvPicPr>
           <p:cNvPr id="2" name="Picture 1" descr="slide-002.png"/>
@@ -3429,7 +4105,6 @@
           <a:lstStyle/>
           <a:p>
             <a:pPr algn="ctr"/>
-            <a:endParaRPr/>
           </a:p>
         </p:txBody>
       </p:sp>
@@ -3473,7 +4148,6 @@
           <a:lstStyle/>
           <a:p>
             <a:pPr algn="ctr"/>
-            <a:endParaRPr/>
           </a:p>
         </p:txBody>
       </p:sp>
@@ -3486,7 +4160,7 @@
 </file>
 
 <file path=ppt/slides/slide3.xml><?xml version="1.0" encoding="utf-8"?>
-<p:sld xmlns:a="http://schemas.openxmlformats.org/drawingml/2006/main" xmlns:r="http://schemas.openxmlformats.org/officeDocument/2006/relationships" xmlns:p="http://schemas.openxmlformats.org/presentationml/2006/main">
+<p:sld xmlns:a="http://schemas.openxmlformats.org/drawingml/2006/main" xmlns:p="http://schemas.openxmlformats.org/presentationml/2006/main" xmlns:r="http://schemas.openxmlformats.org/officeDocument/2006/relationships">
   <p:cSld>
     <p:spTree>
       <p:nvGrpSpPr>
@@ -3494,14 +4168,7 @@
         <p:cNvGrpSpPr/>
         <p:nvPr/>
       </p:nvGrpSpPr>
-      <p:grpSpPr>
-        <a:xfrm>
-          <a:off x="0" y="0"/>
-          <a:ext cx="0" cy="0"/>
-          <a:chOff x="0" y="0"/>
-          <a:chExt cx="0" cy="0"/>
-        </a:xfrm>
-      </p:grpSpPr>
+      <p:grpSpPr/>
       <p:pic>
         <p:nvPicPr>
           <p:cNvPr id="2" name="Picture 1" descr="slide-003.png"/>
@@ -3566,7 +4233,6 @@
           <a:lstStyle/>
           <a:p>
             <a:pPr algn="ctr"/>
-            <a:endParaRPr/>
           </a:p>
         </p:txBody>
       </p:sp>
@@ -3610,7 +4276,6 @@
           <a:lstStyle/>
           <a:p>
             <a:pPr algn="ctr"/>
-            <a:endParaRPr/>
           </a:p>
         </p:txBody>
       </p:sp>
@@ -3623,7 +4288,7 @@
 </file>
 
 <file path=ppt/slides/slide4.xml><?xml version="1.0" encoding="utf-8"?>
-<p:sld xmlns:a="http://schemas.openxmlformats.org/drawingml/2006/main" xmlns:r="http://schemas.openxmlformats.org/officeDocument/2006/relationships" xmlns:p="http://schemas.openxmlformats.org/presentationml/2006/main">
+<p:sld xmlns:a="http://schemas.openxmlformats.org/drawingml/2006/main" xmlns:p="http://schemas.openxmlformats.org/presentationml/2006/main" xmlns:r="http://schemas.openxmlformats.org/officeDocument/2006/relationships">
   <p:cSld>
     <p:spTree>
       <p:nvGrpSpPr>
@@ -3631,14 +4296,7 @@
         <p:cNvGrpSpPr/>
         <p:nvPr/>
       </p:nvGrpSpPr>
-      <p:grpSpPr>
-        <a:xfrm>
-          <a:off x="0" y="0"/>
-          <a:ext cx="0" cy="0"/>
-          <a:chOff x="0" y="0"/>
-          <a:chExt cx="0" cy="0"/>
-        </a:xfrm>
-      </p:grpSpPr>
+      <p:grpSpPr/>
       <p:pic>
         <p:nvPicPr>
           <p:cNvPr id="2" name="Picture 1" descr="slide-004.png"/>
@@ -3703,7 +4361,6 @@
           <a:lstStyle/>
           <a:p>
             <a:pPr algn="ctr"/>
-            <a:endParaRPr/>
           </a:p>
         </p:txBody>
       </p:sp>
@@ -3747,7 +4404,6 @@
           <a:lstStyle/>
           <a:p>
             <a:pPr algn="ctr"/>
-            <a:endParaRPr/>
           </a:p>
         </p:txBody>
       </p:sp>
@@ -3760,7 +4416,7 @@
 </file>
 
 <file path=ppt/slides/slide5.xml><?xml version="1.0" encoding="utf-8"?>
-<p:sld xmlns:a="http://schemas.openxmlformats.org/drawingml/2006/main" xmlns:r="http://schemas.openxmlformats.org/officeDocument/2006/relationships" xmlns:p="http://schemas.openxmlformats.org/presentationml/2006/main">
+<p:sld xmlns:a="http://schemas.openxmlformats.org/drawingml/2006/main" xmlns:p="http://schemas.openxmlformats.org/presentationml/2006/main" xmlns:r="http://schemas.openxmlformats.org/officeDocument/2006/relationships">
   <p:cSld>
     <p:spTree>
       <p:nvGrpSpPr>
@@ -3768,14 +4424,7 @@
         <p:cNvGrpSpPr/>
         <p:nvPr/>
       </p:nvGrpSpPr>
-      <p:grpSpPr>
-        <a:xfrm>
-          <a:off x="0" y="0"/>
-          <a:ext cx="0" cy="0"/>
-          <a:chOff x="0" y="0"/>
-          <a:chExt cx="0" cy="0"/>
-        </a:xfrm>
-      </p:grpSpPr>
+      <p:grpSpPr/>
       <p:pic>
         <p:nvPicPr>
           <p:cNvPr id="2" name="Picture 1" descr="slide-005.png"/>
@@ -3840,7 +4489,6 @@
           <a:lstStyle/>
           <a:p>
             <a:pPr algn="ctr"/>
-            <a:endParaRPr/>
           </a:p>
         </p:txBody>
       </p:sp>
@@ -3884,7 +4532,6 @@
           <a:lstStyle/>
           <a:p>
             <a:pPr algn="ctr"/>
-            <a:endParaRPr/>
           </a:p>
         </p:txBody>
       </p:sp>
@@ -3897,7 +4544,7 @@
 </file>
 
 <file path=ppt/slides/slide6.xml><?xml version="1.0" encoding="utf-8"?>
-<p:sld xmlns:a="http://schemas.openxmlformats.org/drawingml/2006/main" xmlns:r="http://schemas.openxmlformats.org/officeDocument/2006/relationships" xmlns:p="http://schemas.openxmlformats.org/presentationml/2006/main">
+<p:sld xmlns:a="http://schemas.openxmlformats.org/drawingml/2006/main" xmlns:p="http://schemas.openxmlformats.org/presentationml/2006/main" xmlns:r="http://schemas.openxmlformats.org/officeDocument/2006/relationships">
   <p:cSld>
     <p:spTree>
       <p:nvGrpSpPr>
@@ -3905,14 +4552,7 @@
         <p:cNvGrpSpPr/>
         <p:nvPr/>
       </p:nvGrpSpPr>
-      <p:grpSpPr>
-        <a:xfrm>
-          <a:off x="0" y="0"/>
-          <a:ext cx="0" cy="0"/>
-          <a:chOff x="0" y="0"/>
-          <a:chExt cx="0" cy="0"/>
-        </a:xfrm>
-      </p:grpSpPr>
+      <p:grpSpPr/>
       <p:pic>
         <p:nvPicPr>
           <p:cNvPr id="2" name="Picture 1" descr="slide-006.png"/>
@@ -3977,7 +4617,6 @@
           <a:lstStyle/>
           <a:p>
             <a:pPr algn="ctr"/>
-            <a:endParaRPr/>
           </a:p>
         </p:txBody>
       </p:sp>
@@ -4021,7 +4660,6 @@
           <a:lstStyle/>
           <a:p>
             <a:pPr algn="ctr"/>
-            <a:endParaRPr/>
           </a:p>
         </p:txBody>
       </p:sp>
@@ -4034,7 +4672,7 @@
 </file>
 
 <file path=ppt/slides/slide7.xml><?xml version="1.0" encoding="utf-8"?>
-<p:sld xmlns:a="http://schemas.openxmlformats.org/drawingml/2006/main" xmlns:r="http://schemas.openxmlformats.org/officeDocument/2006/relationships" xmlns:p="http://schemas.openxmlformats.org/presentationml/2006/main">
+<p:sld xmlns:a="http://schemas.openxmlformats.org/drawingml/2006/main" xmlns:p="http://schemas.openxmlformats.org/presentationml/2006/main" xmlns:r="http://schemas.openxmlformats.org/officeDocument/2006/relationships">
   <p:cSld>
     <p:spTree>
       <p:nvGrpSpPr>
@@ -4042,14 +4680,7 @@
         <p:cNvGrpSpPr/>
         <p:nvPr/>
       </p:nvGrpSpPr>
-      <p:grpSpPr>
-        <a:xfrm>
-          <a:off x="0" y="0"/>
-          <a:ext cx="0" cy="0"/>
-          <a:chOff x="0" y="0"/>
-          <a:chExt cx="0" cy="0"/>
-        </a:xfrm>
-      </p:grpSpPr>
+      <p:grpSpPr/>
       <p:pic>
         <p:nvPicPr>
           <p:cNvPr id="2" name="Picture 1" descr="slide-007.png"/>
@@ -4074,6 +4705,348 @@
           </a:prstGeom>
         </p:spPr>
       </p:pic>
+      <p:sp>
+        <p:nvSpPr>
+          <p:cNvPr id="3" name="Rectangle 2">
+            <a:hlinkClick r:id="rId3"/>
+          </p:cNvPr>
+          <p:cNvSpPr/>
+          <p:nvPr/>
+        </p:nvSpPr>
+        <p:spPr>
+          <a:xfrm>
+            <a:off x="9509760" y="384048"/>
+            <a:ext cx="1828800" cy="310896"/>
+          </a:xfrm>
+          <a:prstGeom prst="rect">
+            <a:avLst/>
+          </a:prstGeom>
+          <a:noFill/>
+          <a:ln>
+            <a:noFill/>
+          </a:ln>
+        </p:spPr>
+        <p:style>
+          <a:lnRef idx="1">
+            <a:schemeClr val="accent1"/>
+          </a:lnRef>
+          <a:fillRef idx="3">
+            <a:schemeClr val="accent1"/>
+          </a:fillRef>
+          <a:effectRef idx="2">
+            <a:schemeClr val="accent1"/>
+          </a:effectRef>
+          <a:fontRef idx="minor">
+            <a:schemeClr val="lt1"/>
+          </a:fontRef>
+        </p:style>
+        <p:txBody>
+          <a:bodyPr rtlCol="0" anchor="ctr"/>
+          <a:lstStyle/>
+          <a:p>
+            <a:pPr algn="ctr"/>
+          </a:p>
+        </p:txBody>
+      </p:sp>
+      <p:sp>
+        <p:nvSpPr>
+          <p:cNvPr id="4" name="Rectangle 3">
+            <a:hlinkClick r:id="rId3"/>
+          </p:cNvPr>
+          <p:cNvSpPr/>
+          <p:nvPr/>
+        </p:nvSpPr>
+        <p:spPr>
+          <a:xfrm>
+            <a:off x="6400800" y="6473952"/>
+            <a:ext cx="4937760" cy="201168"/>
+          </a:xfrm>
+          <a:prstGeom prst="rect">
+            <a:avLst/>
+          </a:prstGeom>
+          <a:noFill/>
+          <a:ln>
+            <a:noFill/>
+          </a:ln>
+        </p:spPr>
+        <p:style>
+          <a:lnRef idx="1">
+            <a:schemeClr val="accent1"/>
+          </a:lnRef>
+          <a:fillRef idx="3">
+            <a:schemeClr val="accent1"/>
+          </a:fillRef>
+          <a:effectRef idx="2">
+            <a:schemeClr val="accent1"/>
+          </a:effectRef>
+          <a:fontRef idx="minor">
+            <a:schemeClr val="lt1"/>
+          </a:fontRef>
+        </p:style>
+        <p:txBody>
+          <a:bodyPr rtlCol="0" anchor="ctr"/>
+          <a:lstStyle/>
+          <a:p>
+            <a:pPr algn="ctr"/>
+          </a:p>
+        </p:txBody>
+      </p:sp>
+    </p:spTree>
+  </p:cSld>
+  <p:clrMapOvr>
+    <a:masterClrMapping/>
+  </p:clrMapOvr>
+</p:sld>
+</file>
+
+<file path=ppt/slides/slide8.xml><?xml version="1.0" encoding="utf-8"?>
+<p:sld xmlns:a="http://schemas.openxmlformats.org/drawingml/2006/main" xmlns:p="http://schemas.openxmlformats.org/presentationml/2006/main" xmlns:r="http://schemas.openxmlformats.org/officeDocument/2006/relationships">
+  <p:cSld>
+    <p:spTree>
+      <p:nvGrpSpPr>
+        <p:cNvPr id="1" name=""/>
+        <p:cNvGrpSpPr/>
+        <p:nvPr/>
+      </p:nvGrpSpPr>
+      <p:grpSpPr/>
+      <p:pic>
+        <p:nvPicPr>
+          <p:cNvPr id="2" name="Picture 1" descr="slide-008.png"/>
+          <p:cNvPicPr>
+            <a:picLocks noChangeAspect="1"/>
+          </p:cNvPicPr>
+          <p:nvPr/>
+        </p:nvPicPr>
+        <p:blipFill>
+          <a:blip r:embed="rId2"/>
+          <a:stretch>
+            <a:fillRect/>
+          </a:stretch>
+        </p:blipFill>
+        <p:spPr>
+          <a:xfrm>
+            <a:off x="0" y="0"/>
+            <a:ext cx="12191999" cy="6858000"/>
+          </a:xfrm>
+          <a:prstGeom prst="rect">
+            <a:avLst/>
+          </a:prstGeom>
+        </p:spPr>
+      </p:pic>
+      <p:sp>
+        <p:nvSpPr>
+          <p:cNvPr id="3" name="Rectangle 2">
+            <a:hlinkClick r:id="rId3"/>
+          </p:cNvPr>
+          <p:cNvSpPr/>
+          <p:nvPr/>
+        </p:nvSpPr>
+        <p:spPr>
+          <a:xfrm>
+            <a:off x="9509760" y="384048"/>
+            <a:ext cx="1828800" cy="310896"/>
+          </a:xfrm>
+          <a:prstGeom prst="rect">
+            <a:avLst/>
+          </a:prstGeom>
+          <a:noFill/>
+          <a:ln>
+            <a:noFill/>
+          </a:ln>
+        </p:spPr>
+        <p:style>
+          <a:lnRef idx="1">
+            <a:schemeClr val="accent1"/>
+          </a:lnRef>
+          <a:fillRef idx="3">
+            <a:schemeClr val="accent1"/>
+          </a:fillRef>
+          <a:effectRef idx="2">
+            <a:schemeClr val="accent1"/>
+          </a:effectRef>
+          <a:fontRef idx="minor">
+            <a:schemeClr val="lt1"/>
+          </a:fontRef>
+        </p:style>
+        <p:txBody>
+          <a:bodyPr rtlCol="0" anchor="ctr"/>
+          <a:lstStyle/>
+          <a:p>
+            <a:pPr algn="ctr"/>
+          </a:p>
+        </p:txBody>
+      </p:sp>
+      <p:sp>
+        <p:nvSpPr>
+          <p:cNvPr id="4" name="Rectangle 3">
+            <a:hlinkClick r:id="rId3"/>
+          </p:cNvPr>
+          <p:cNvSpPr/>
+          <p:nvPr/>
+        </p:nvSpPr>
+        <p:spPr>
+          <a:xfrm>
+            <a:off x="6400800" y="6473952"/>
+            <a:ext cx="4937760" cy="201168"/>
+          </a:xfrm>
+          <a:prstGeom prst="rect">
+            <a:avLst/>
+          </a:prstGeom>
+          <a:noFill/>
+          <a:ln>
+            <a:noFill/>
+          </a:ln>
+        </p:spPr>
+        <p:style>
+          <a:lnRef idx="1">
+            <a:schemeClr val="accent1"/>
+          </a:lnRef>
+          <a:fillRef idx="3">
+            <a:schemeClr val="accent1"/>
+          </a:fillRef>
+          <a:effectRef idx="2">
+            <a:schemeClr val="accent1"/>
+          </a:effectRef>
+          <a:fontRef idx="minor">
+            <a:schemeClr val="lt1"/>
+          </a:fontRef>
+        </p:style>
+        <p:txBody>
+          <a:bodyPr rtlCol="0" anchor="ctr"/>
+          <a:lstStyle/>
+          <a:p>
+            <a:pPr algn="ctr"/>
+          </a:p>
+        </p:txBody>
+      </p:sp>
+    </p:spTree>
+  </p:cSld>
+  <p:clrMapOvr>
+    <a:masterClrMapping/>
+  </p:clrMapOvr>
+</p:sld>
+</file>
+
+<file path=ppt/slides/slide9.xml><?xml version="1.0" encoding="utf-8"?>
+<p:sld xmlns:a="http://schemas.openxmlformats.org/drawingml/2006/main" xmlns:p="http://schemas.openxmlformats.org/presentationml/2006/main" xmlns:r="http://schemas.openxmlformats.org/officeDocument/2006/relationships">
+  <p:cSld>
+    <p:spTree>
+      <p:nvGrpSpPr>
+        <p:cNvPr id="1" name=""/>
+        <p:cNvGrpSpPr/>
+        <p:nvPr/>
+      </p:nvGrpSpPr>
+      <p:grpSpPr/>
+      <p:pic>
+        <p:nvPicPr>
+          <p:cNvPr id="2" name="Picture 1" descr="slide-009.png"/>
+          <p:cNvPicPr>
+            <a:picLocks noChangeAspect="1"/>
+          </p:cNvPicPr>
+          <p:nvPr/>
+        </p:nvPicPr>
+        <p:blipFill>
+          <a:blip r:embed="rId2"/>
+          <a:stretch>
+            <a:fillRect/>
+          </a:stretch>
+        </p:blipFill>
+        <p:spPr>
+          <a:xfrm>
+            <a:off x="0" y="0"/>
+            <a:ext cx="12191999" cy="6858000"/>
+          </a:xfrm>
+          <a:prstGeom prst="rect">
+            <a:avLst/>
+          </a:prstGeom>
+        </p:spPr>
+      </p:pic>
+      <p:sp>
+        <p:nvSpPr>
+          <p:cNvPr id="3" name="Rectangle 2">
+            <a:hlinkClick r:id="rId3"/>
+          </p:cNvPr>
+          <p:cNvSpPr/>
+          <p:nvPr/>
+        </p:nvSpPr>
+        <p:spPr>
+          <a:xfrm>
+            <a:off x="9509760" y="384048"/>
+            <a:ext cx="1828800" cy="310896"/>
+          </a:xfrm>
+          <a:prstGeom prst="rect">
+            <a:avLst/>
+          </a:prstGeom>
+          <a:noFill/>
+          <a:ln>
+            <a:noFill/>
+          </a:ln>
+        </p:spPr>
+        <p:style>
+          <a:lnRef idx="1">
+            <a:schemeClr val="accent1"/>
+          </a:lnRef>
+          <a:fillRef idx="3">
+            <a:schemeClr val="accent1"/>
+          </a:fillRef>
+          <a:effectRef idx="2">
+            <a:schemeClr val="accent1"/>
+          </a:effectRef>
+          <a:fontRef idx="minor">
+            <a:schemeClr val="lt1"/>
+          </a:fontRef>
+        </p:style>
+        <p:txBody>
+          <a:bodyPr rtlCol="0" anchor="ctr"/>
+          <a:lstStyle/>
+          <a:p>
+            <a:pPr algn="ctr"/>
+          </a:p>
+        </p:txBody>
+      </p:sp>
+      <p:sp>
+        <p:nvSpPr>
+          <p:cNvPr id="4" name="Rectangle 3">
+            <a:hlinkClick r:id="rId3"/>
+          </p:cNvPr>
+          <p:cNvSpPr/>
+          <p:nvPr/>
+        </p:nvSpPr>
+        <p:spPr>
+          <a:xfrm>
+            <a:off x="6400800" y="6473952"/>
+            <a:ext cx="4937760" cy="201168"/>
+          </a:xfrm>
+          <a:prstGeom prst="rect">
+            <a:avLst/>
+          </a:prstGeom>
+          <a:noFill/>
+          <a:ln>
+            <a:noFill/>
+          </a:ln>
+        </p:spPr>
+        <p:style>
+          <a:lnRef idx="1">
+            <a:schemeClr val="accent1"/>
+          </a:lnRef>
+          <a:fillRef idx="3">
+            <a:schemeClr val="accent1"/>
+          </a:fillRef>
+          <a:effectRef idx="2">
+            <a:schemeClr val="accent1"/>
+          </a:effectRef>
+          <a:fontRef idx="minor">
+            <a:schemeClr val="lt1"/>
+          </a:fontRef>
+        </p:style>
+        <p:txBody>
+          <a:bodyPr rtlCol="0" anchor="ctr"/>
+          <a:lstStyle/>
+          <a:p>
+            <a:pPr algn="ctr"/>
+          </a:p>
+        </p:txBody>
+      </p:sp>
     </p:spTree>
   </p:cSld>
   <p:clrMapOvr>

</xml_diff>

<commit_message>
Fix PubMed lymphoma slides 2026-06-08 to five papers
</commit_message>
<xml_diff>
--- a/archive/2026-06-08/pubmed-dlbcl-cnsl-btki-2026-06-08.pptx
+++ b/archive/2026-06-08/pubmed-dlbcl-cnsl-btki-2026-06-08.pptx
@@ -5,21 +5,15 @@
     <p:sldMasterId id="2147483648" r:id="rId1"/>
   </p:sldMasterIdLst>
   <p:sldIdLst>
-    <p:sldId id="256" r:id="rId7"/>
-    <p:sldId id="257" r:id="rId8"/>
-    <p:sldId id="258" r:id="rId9"/>
-    <p:sldId id="259" r:id="rId10"/>
-    <p:sldId id="260" r:id="rId11"/>
-    <p:sldId id="261" r:id="rId12"/>
-    <p:sldId id="262" r:id="rId13"/>
-    <p:sldId id="263" r:id="rId14"/>
-    <p:sldId id="264" r:id="rId15"/>
-    <p:sldId id="265" r:id="rId16"/>
-    <p:sldId id="266" r:id="rId17"/>
-    <p:sldId id="267" r:id="rId18"/>
-    <p:sldId id="268" r:id="rId19"/>
+    <p:sldId id="256" r:id="rId2"/>
+    <p:sldId id="257" r:id="rId3"/>
+    <p:sldId id="258" r:id="rId4"/>
+    <p:sldId id="259" r:id="rId5"/>
+    <p:sldId id="260" r:id="rId6"/>
+    <p:sldId id="261" r:id="rId7"/>
+    <p:sldId id="262" r:id="rId8"/>
   </p:sldIdLst>
-  <p:sldSz cx="12191999" cy="6858000" type="screen4x3"/>
+  <p:sldSz cx="12192000" cy="6858000"/>
   <p:notesSz cx="6858000" cy="9144000"/>
   <p:defaultTextStyle>
     <a:defPPr>
@@ -116,6 +110,22 @@
       </a:defRPr>
     </a:lvl9pPr>
   </p:defaultTextStyle>
+  <p:extLst>
+    <p:ext uri="{EFAFB233-063F-42B5-8137-9DF3F51BA10A}">
+      <p15:sldGuideLst xmlns:p15="http://schemas.microsoft.com/office/powerpoint/2012/main">
+        <p15:guide id="1" orient="horz" pos="2160">
+          <p15:clr>
+            <a:srgbClr val="A4A3A4"/>
+          </p15:clr>
+        </p15:guide>
+        <p15:guide id="2" pos="2880">
+          <p15:clr>
+            <a:srgbClr val="A4A3A4"/>
+          </p15:clr>
+        </p15:guide>
+      </p15:sldGuideLst>
+    </p:ext>
+  </p:extLst>
 </p:presentation>
 </file>
 
@@ -157,10 +167,9 @@
           <a:lstStyle/>
           <a:p>
             <a:r>
-              <a:rPr lang="en-US" smtClean="0"/>
+              <a:rPr lang="en-US"/>
               <a:t>Click to edit Master title style</a:t>
             </a:r>
-            <a:endParaRPr lang="en-US"/>
           </a:p>
         </p:txBody>
       </p:sp>
@@ -276,10 +285,9 @@
           </a:lstStyle>
           <a:p>
             <a:r>
-              <a:rPr lang="en-US" smtClean="0"/>
+              <a:rPr lang="en-US"/>
               <a:t>Click to edit Master subtitle style</a:t>
             </a:r>
-            <a:endParaRPr lang="en-US"/>
           </a:p>
         </p:txBody>
       </p:sp>
@@ -300,7 +308,7 @@
           <a:p>
             <a:fld id="{5BCAD085-E8A6-8845-BD4E-CB4CCA059FC4}" type="datetimeFigureOut">
               <a:rPr lang="en-US" smtClean="0"/>
-              <a:t>1/27/13</a:t>
+              <a:t>6/8/2026</a:t>
             </a:fld>
             <a:endParaRPr lang="en-US"/>
           </a:p>
@@ -394,10 +402,9 @@
           <a:lstStyle/>
           <a:p>
             <a:r>
-              <a:rPr lang="en-US" smtClean="0"/>
+              <a:rPr lang="en-US"/>
               <a:t>Click to edit Master title style</a:t>
             </a:r>
-            <a:endParaRPr lang="en-US"/>
           </a:p>
         </p:txBody>
       </p:sp>
@@ -418,38 +425,37 @@
           <a:p>
             <a:pPr lvl="0"/>
             <a:r>
-              <a:rPr lang="en-US" smtClean="0"/>
+              <a:rPr lang="en-US"/>
               <a:t>Click to edit Master text styles</a:t>
             </a:r>
           </a:p>
           <a:p>
             <a:pPr lvl="1"/>
             <a:r>
-              <a:rPr lang="en-US" smtClean="0"/>
+              <a:rPr lang="en-US"/>
               <a:t>Second level</a:t>
             </a:r>
           </a:p>
           <a:p>
             <a:pPr lvl="2"/>
             <a:r>
-              <a:rPr lang="en-US" smtClean="0"/>
+              <a:rPr lang="en-US"/>
               <a:t>Third level</a:t>
             </a:r>
           </a:p>
           <a:p>
             <a:pPr lvl="3"/>
             <a:r>
-              <a:rPr lang="en-US" smtClean="0"/>
+              <a:rPr lang="en-US"/>
               <a:t>Fourth level</a:t>
             </a:r>
           </a:p>
           <a:p>
             <a:pPr lvl="4"/>
             <a:r>
-              <a:rPr lang="en-US" smtClean="0"/>
+              <a:rPr lang="en-US"/>
               <a:t>Fifth level</a:t>
             </a:r>
-            <a:endParaRPr lang="en-US"/>
           </a:p>
         </p:txBody>
       </p:sp>
@@ -470,7 +476,7 @@
           <a:p>
             <a:fld id="{5BCAD085-E8A6-8845-BD4E-CB4CCA059FC4}" type="datetimeFigureOut">
               <a:rPr lang="en-US" smtClean="0"/>
-              <a:t>1/27/13</a:t>
+              <a:t>6/8/2026</a:t>
             </a:fld>
             <a:endParaRPr lang="en-US"/>
           </a:p>
@@ -569,10 +575,9 @@
           <a:lstStyle/>
           <a:p>
             <a:r>
-              <a:rPr lang="en-US" smtClean="0"/>
+              <a:rPr lang="en-US"/>
               <a:t>Click to edit Master title style</a:t>
             </a:r>
-            <a:endParaRPr lang="en-US"/>
           </a:p>
         </p:txBody>
       </p:sp>
@@ -598,38 +603,37 @@
           <a:p>
             <a:pPr lvl="0"/>
             <a:r>
-              <a:rPr lang="en-US" smtClean="0"/>
+              <a:rPr lang="en-US"/>
               <a:t>Click to edit Master text styles</a:t>
             </a:r>
           </a:p>
           <a:p>
             <a:pPr lvl="1"/>
             <a:r>
-              <a:rPr lang="en-US" smtClean="0"/>
+              <a:rPr lang="en-US"/>
               <a:t>Second level</a:t>
             </a:r>
           </a:p>
           <a:p>
             <a:pPr lvl="2"/>
             <a:r>
-              <a:rPr lang="en-US" smtClean="0"/>
+              <a:rPr lang="en-US"/>
               <a:t>Third level</a:t>
             </a:r>
           </a:p>
           <a:p>
             <a:pPr lvl="3"/>
             <a:r>
-              <a:rPr lang="en-US" smtClean="0"/>
+              <a:rPr lang="en-US"/>
               <a:t>Fourth level</a:t>
             </a:r>
           </a:p>
           <a:p>
             <a:pPr lvl="4"/>
             <a:r>
-              <a:rPr lang="en-US" smtClean="0"/>
+              <a:rPr lang="en-US"/>
               <a:t>Fifth level</a:t>
             </a:r>
-            <a:endParaRPr lang="en-US"/>
           </a:p>
         </p:txBody>
       </p:sp>
@@ -650,7 +654,7 @@
           <a:p>
             <a:fld id="{5BCAD085-E8A6-8845-BD4E-CB4CCA059FC4}" type="datetimeFigureOut">
               <a:rPr lang="en-US" smtClean="0"/>
-              <a:t>1/27/13</a:t>
+              <a:t>6/8/2026</a:t>
             </a:fld>
             <a:endParaRPr lang="en-US"/>
           </a:p>
@@ -744,10 +748,9 @@
           <a:lstStyle/>
           <a:p>
             <a:r>
-              <a:rPr lang="en-US" smtClean="0"/>
+              <a:rPr lang="en-US"/>
               <a:t>Click to edit Master title style</a:t>
             </a:r>
-            <a:endParaRPr lang="en-US"/>
           </a:p>
         </p:txBody>
       </p:sp>
@@ -768,38 +771,37 @@
           <a:p>
             <a:pPr lvl="0"/>
             <a:r>
-              <a:rPr lang="en-US" smtClean="0"/>
+              <a:rPr lang="en-US"/>
               <a:t>Click to edit Master text styles</a:t>
             </a:r>
           </a:p>
           <a:p>
             <a:pPr lvl="1"/>
             <a:r>
-              <a:rPr lang="en-US" smtClean="0"/>
+              <a:rPr lang="en-US"/>
               <a:t>Second level</a:t>
             </a:r>
           </a:p>
           <a:p>
             <a:pPr lvl="2"/>
             <a:r>
-              <a:rPr lang="en-US" smtClean="0"/>
+              <a:rPr lang="en-US"/>
               <a:t>Third level</a:t>
             </a:r>
           </a:p>
           <a:p>
             <a:pPr lvl="3"/>
             <a:r>
-              <a:rPr lang="en-US" smtClean="0"/>
+              <a:rPr lang="en-US"/>
               <a:t>Fourth level</a:t>
             </a:r>
           </a:p>
           <a:p>
             <a:pPr lvl="4"/>
             <a:r>
-              <a:rPr lang="en-US" smtClean="0"/>
+              <a:rPr lang="en-US"/>
               <a:t>Fifth level</a:t>
             </a:r>
-            <a:endParaRPr lang="en-US"/>
           </a:p>
         </p:txBody>
       </p:sp>
@@ -820,7 +822,7 @@
           <a:p>
             <a:fld id="{5BCAD085-E8A6-8845-BD4E-CB4CCA059FC4}" type="datetimeFigureOut">
               <a:rPr lang="en-US" smtClean="0"/>
-              <a:t>1/27/13</a:t>
+              <a:t>6/8/2026</a:t>
             </a:fld>
             <a:endParaRPr lang="en-US"/>
           </a:p>
@@ -923,10 +925,9 @@
           </a:lstStyle>
           <a:p>
             <a:r>
-              <a:rPr lang="en-US" smtClean="0"/>
+              <a:rPr lang="en-US"/>
               <a:t>Click to edit Master title style</a:t>
             </a:r>
-            <a:endParaRPr lang="en-US"/>
           </a:p>
         </p:txBody>
       </p:sp>
@@ -1043,7 +1044,7 @@
           <a:p>
             <a:pPr lvl="0"/>
             <a:r>
-              <a:rPr lang="en-US" smtClean="0"/>
+              <a:rPr lang="en-US"/>
               <a:t>Click to edit Master text styles</a:t>
             </a:r>
           </a:p>
@@ -1066,7 +1067,7 @@
           <a:p>
             <a:fld id="{5BCAD085-E8A6-8845-BD4E-CB4CCA059FC4}" type="datetimeFigureOut">
               <a:rPr lang="en-US" smtClean="0"/>
-              <a:t>1/27/13</a:t>
+              <a:t>6/8/2026</a:t>
             </a:fld>
             <a:endParaRPr lang="en-US"/>
           </a:p>
@@ -1160,10 +1161,9 @@
           <a:lstStyle/>
           <a:p>
             <a:r>
-              <a:rPr lang="en-US" smtClean="0"/>
+              <a:rPr lang="en-US"/>
               <a:t>Click to edit Master title style</a:t>
             </a:r>
-            <a:endParaRPr lang="en-US"/>
           </a:p>
         </p:txBody>
       </p:sp>
@@ -1217,38 +1217,37 @@
           <a:p>
             <a:pPr lvl="0"/>
             <a:r>
-              <a:rPr lang="en-US" smtClean="0"/>
+              <a:rPr lang="en-US"/>
               <a:t>Click to edit Master text styles</a:t>
             </a:r>
           </a:p>
           <a:p>
             <a:pPr lvl="1"/>
             <a:r>
-              <a:rPr lang="en-US" smtClean="0"/>
+              <a:rPr lang="en-US"/>
               <a:t>Second level</a:t>
             </a:r>
           </a:p>
           <a:p>
             <a:pPr lvl="2"/>
             <a:r>
-              <a:rPr lang="en-US" smtClean="0"/>
+              <a:rPr lang="en-US"/>
               <a:t>Third level</a:t>
             </a:r>
           </a:p>
           <a:p>
             <a:pPr lvl="3"/>
             <a:r>
-              <a:rPr lang="en-US" smtClean="0"/>
+              <a:rPr lang="en-US"/>
               <a:t>Fourth level</a:t>
             </a:r>
           </a:p>
           <a:p>
             <a:pPr lvl="4"/>
             <a:r>
-              <a:rPr lang="en-US" smtClean="0"/>
+              <a:rPr lang="en-US"/>
               <a:t>Fifth level</a:t>
             </a:r>
-            <a:endParaRPr lang="en-US"/>
           </a:p>
         </p:txBody>
       </p:sp>
@@ -1302,38 +1301,37 @@
           <a:p>
             <a:pPr lvl="0"/>
             <a:r>
-              <a:rPr lang="en-US" smtClean="0"/>
+              <a:rPr lang="en-US"/>
               <a:t>Click to edit Master text styles</a:t>
             </a:r>
           </a:p>
           <a:p>
             <a:pPr lvl="1"/>
             <a:r>
-              <a:rPr lang="en-US" smtClean="0"/>
+              <a:rPr lang="en-US"/>
               <a:t>Second level</a:t>
             </a:r>
           </a:p>
           <a:p>
             <a:pPr lvl="2"/>
             <a:r>
-              <a:rPr lang="en-US" smtClean="0"/>
+              <a:rPr lang="en-US"/>
               <a:t>Third level</a:t>
             </a:r>
           </a:p>
           <a:p>
             <a:pPr lvl="3"/>
             <a:r>
-              <a:rPr lang="en-US" smtClean="0"/>
+              <a:rPr lang="en-US"/>
               <a:t>Fourth level</a:t>
             </a:r>
           </a:p>
           <a:p>
             <a:pPr lvl="4"/>
             <a:r>
-              <a:rPr lang="en-US" smtClean="0"/>
+              <a:rPr lang="en-US"/>
               <a:t>Fifth level</a:t>
             </a:r>
-            <a:endParaRPr lang="en-US"/>
           </a:p>
         </p:txBody>
       </p:sp>
@@ -1354,7 +1352,7 @@
           <a:p>
             <a:fld id="{5BCAD085-E8A6-8845-BD4E-CB4CCA059FC4}" type="datetimeFigureOut">
               <a:rPr lang="en-US" smtClean="0"/>
-              <a:t>1/27/13</a:t>
+              <a:t>6/8/2026</a:t>
             </a:fld>
             <a:endParaRPr lang="en-US"/>
           </a:p>
@@ -1452,10 +1450,9 @@
           </a:lstStyle>
           <a:p>
             <a:r>
-              <a:rPr lang="en-US" smtClean="0"/>
+              <a:rPr lang="en-US"/>
               <a:t>Click to edit Master title style</a:t>
             </a:r>
-            <a:endParaRPr lang="en-US"/>
           </a:p>
         </p:txBody>
       </p:sp>
@@ -1518,7 +1515,7 @@
           <a:p>
             <a:pPr lvl="0"/>
             <a:r>
-              <a:rPr lang="en-US" smtClean="0"/>
+              <a:rPr lang="en-US"/>
               <a:t>Click to edit Master text styles</a:t>
             </a:r>
           </a:p>
@@ -1574,38 +1571,37 @@
           <a:p>
             <a:pPr lvl="0"/>
             <a:r>
-              <a:rPr lang="en-US" smtClean="0"/>
+              <a:rPr lang="en-US"/>
               <a:t>Click to edit Master text styles</a:t>
             </a:r>
           </a:p>
           <a:p>
             <a:pPr lvl="1"/>
             <a:r>
-              <a:rPr lang="en-US" smtClean="0"/>
+              <a:rPr lang="en-US"/>
               <a:t>Second level</a:t>
             </a:r>
           </a:p>
           <a:p>
             <a:pPr lvl="2"/>
             <a:r>
-              <a:rPr lang="en-US" smtClean="0"/>
+              <a:rPr lang="en-US"/>
               <a:t>Third level</a:t>
             </a:r>
           </a:p>
           <a:p>
             <a:pPr lvl="3"/>
             <a:r>
-              <a:rPr lang="en-US" smtClean="0"/>
+              <a:rPr lang="en-US"/>
               <a:t>Fourth level</a:t>
             </a:r>
           </a:p>
           <a:p>
             <a:pPr lvl="4"/>
             <a:r>
-              <a:rPr lang="en-US" smtClean="0"/>
+              <a:rPr lang="en-US"/>
               <a:t>Fifth level</a:t>
             </a:r>
-            <a:endParaRPr lang="en-US"/>
           </a:p>
         </p:txBody>
       </p:sp>
@@ -1668,7 +1664,7 @@
           <a:p>
             <a:pPr lvl="0"/>
             <a:r>
-              <a:rPr lang="en-US" smtClean="0"/>
+              <a:rPr lang="en-US"/>
               <a:t>Click to edit Master text styles</a:t>
             </a:r>
           </a:p>
@@ -1724,38 +1720,37 @@
           <a:p>
             <a:pPr lvl="0"/>
             <a:r>
-              <a:rPr lang="en-US" smtClean="0"/>
+              <a:rPr lang="en-US"/>
               <a:t>Click to edit Master text styles</a:t>
             </a:r>
           </a:p>
           <a:p>
             <a:pPr lvl="1"/>
             <a:r>
-              <a:rPr lang="en-US" smtClean="0"/>
+              <a:rPr lang="en-US"/>
               <a:t>Second level</a:t>
             </a:r>
           </a:p>
           <a:p>
             <a:pPr lvl="2"/>
             <a:r>
-              <a:rPr lang="en-US" smtClean="0"/>
+              <a:rPr lang="en-US"/>
               <a:t>Third level</a:t>
             </a:r>
           </a:p>
           <a:p>
             <a:pPr lvl="3"/>
             <a:r>
-              <a:rPr lang="en-US" smtClean="0"/>
+              <a:rPr lang="en-US"/>
               <a:t>Fourth level</a:t>
             </a:r>
           </a:p>
           <a:p>
             <a:pPr lvl="4"/>
             <a:r>
-              <a:rPr lang="en-US" smtClean="0"/>
+              <a:rPr lang="en-US"/>
               <a:t>Fifth level</a:t>
             </a:r>
-            <a:endParaRPr lang="en-US"/>
           </a:p>
         </p:txBody>
       </p:sp>
@@ -1776,7 +1771,7 @@
           <a:p>
             <a:fld id="{5BCAD085-E8A6-8845-BD4E-CB4CCA059FC4}" type="datetimeFigureOut">
               <a:rPr lang="en-US" smtClean="0"/>
-              <a:t>1/27/13</a:t>
+              <a:t>6/8/2026</a:t>
             </a:fld>
             <a:endParaRPr lang="en-US"/>
           </a:p>
@@ -1870,10 +1865,9 @@
           <a:lstStyle/>
           <a:p>
             <a:r>
-              <a:rPr lang="en-US" smtClean="0"/>
+              <a:rPr lang="en-US"/>
               <a:t>Click to edit Master title style</a:t>
             </a:r>
-            <a:endParaRPr lang="en-US"/>
           </a:p>
         </p:txBody>
       </p:sp>
@@ -1894,7 +1888,7 @@
           <a:p>
             <a:fld id="{5BCAD085-E8A6-8845-BD4E-CB4CCA059FC4}" type="datetimeFigureOut">
               <a:rPr lang="en-US" smtClean="0"/>
-              <a:t>1/27/13</a:t>
+              <a:t>6/8/2026</a:t>
             </a:fld>
             <a:endParaRPr lang="en-US"/>
           </a:p>
@@ -1989,7 +1983,7 @@
           <a:p>
             <a:fld id="{5BCAD085-E8A6-8845-BD4E-CB4CCA059FC4}" type="datetimeFigureOut">
               <a:rPr lang="en-US" smtClean="0"/>
-              <a:t>1/27/13</a:t>
+              <a:t>6/8/2026</a:t>
             </a:fld>
             <a:endParaRPr lang="en-US"/>
           </a:p>
@@ -2092,10 +2086,9 @@
           </a:lstStyle>
           <a:p>
             <a:r>
-              <a:rPr lang="en-US" smtClean="0"/>
+              <a:rPr lang="en-US"/>
               <a:t>Click to edit Master title style</a:t>
             </a:r>
-            <a:endParaRPr lang="en-US"/>
           </a:p>
         </p:txBody>
       </p:sp>
@@ -2149,38 +2142,37 @@
           <a:p>
             <a:pPr lvl="0"/>
             <a:r>
-              <a:rPr lang="en-US" smtClean="0"/>
+              <a:rPr lang="en-US"/>
               <a:t>Click to edit Master text styles</a:t>
             </a:r>
           </a:p>
           <a:p>
             <a:pPr lvl="1"/>
             <a:r>
-              <a:rPr lang="en-US" smtClean="0"/>
+              <a:rPr lang="en-US"/>
               <a:t>Second level</a:t>
             </a:r>
           </a:p>
           <a:p>
             <a:pPr lvl="2"/>
             <a:r>
-              <a:rPr lang="en-US" smtClean="0"/>
+              <a:rPr lang="en-US"/>
               <a:t>Third level</a:t>
             </a:r>
           </a:p>
           <a:p>
             <a:pPr lvl="3"/>
             <a:r>
-              <a:rPr lang="en-US" smtClean="0"/>
+              <a:rPr lang="en-US"/>
               <a:t>Fourth level</a:t>
             </a:r>
           </a:p>
           <a:p>
             <a:pPr lvl="4"/>
             <a:r>
-              <a:rPr lang="en-US" smtClean="0"/>
+              <a:rPr lang="en-US"/>
               <a:t>Fifth level</a:t>
             </a:r>
-            <a:endParaRPr lang="en-US"/>
           </a:p>
         </p:txBody>
       </p:sp>
@@ -2243,7 +2235,7 @@
           <a:p>
             <a:pPr lvl="0"/>
             <a:r>
-              <a:rPr lang="en-US" smtClean="0"/>
+              <a:rPr lang="en-US"/>
               <a:t>Click to edit Master text styles</a:t>
             </a:r>
           </a:p>
@@ -2266,7 +2258,7 @@
           <a:p>
             <a:fld id="{5BCAD085-E8A6-8845-BD4E-CB4CCA059FC4}" type="datetimeFigureOut">
               <a:rPr lang="en-US" smtClean="0"/>
-              <a:t>1/27/13</a:t>
+              <a:t>6/8/2026</a:t>
             </a:fld>
             <a:endParaRPr lang="en-US"/>
           </a:p>
@@ -2369,10 +2361,9 @@
           </a:lstStyle>
           <a:p>
             <a:r>
-              <a:rPr lang="en-US" smtClean="0"/>
+              <a:rPr lang="en-US"/>
               <a:t>Click to edit Master title style</a:t>
             </a:r>
-            <a:endParaRPr lang="en-US"/>
           </a:p>
         </p:txBody>
       </p:sp>
@@ -2496,7 +2487,7 @@
           <a:p>
             <a:pPr lvl="0"/>
             <a:r>
-              <a:rPr lang="en-US" smtClean="0"/>
+              <a:rPr lang="en-US"/>
               <a:t>Click to edit Master text styles</a:t>
             </a:r>
           </a:p>
@@ -2519,7 +2510,7 @@
           <a:p>
             <a:fld id="{5BCAD085-E8A6-8845-BD4E-CB4CCA059FC4}" type="datetimeFigureOut">
               <a:rPr lang="en-US" smtClean="0"/>
-              <a:t>1/27/13</a:t>
+              <a:t>6/8/2026</a:t>
             </a:fld>
             <a:endParaRPr lang="en-US"/>
           </a:p>
@@ -2628,10 +2619,9 @@
           <a:lstStyle/>
           <a:p>
             <a:r>
-              <a:rPr lang="en-US" smtClean="0"/>
+              <a:rPr lang="en-US"/>
               <a:t>Click to edit Master title style</a:t>
             </a:r>
-            <a:endParaRPr lang="en-US"/>
           </a:p>
         </p:txBody>
       </p:sp>
@@ -2662,38 +2652,37 @@
           <a:p>
             <a:pPr lvl="0"/>
             <a:r>
-              <a:rPr lang="en-US" smtClean="0"/>
+              <a:rPr lang="en-US"/>
               <a:t>Click to edit Master text styles</a:t>
             </a:r>
           </a:p>
           <a:p>
             <a:pPr lvl="1"/>
             <a:r>
-              <a:rPr lang="en-US" smtClean="0"/>
+              <a:rPr lang="en-US"/>
               <a:t>Second level</a:t>
             </a:r>
           </a:p>
           <a:p>
             <a:pPr lvl="2"/>
             <a:r>
-              <a:rPr lang="en-US" smtClean="0"/>
+              <a:rPr lang="en-US"/>
               <a:t>Third level</a:t>
             </a:r>
           </a:p>
           <a:p>
             <a:pPr lvl="3"/>
             <a:r>
-              <a:rPr lang="en-US" smtClean="0"/>
+              <a:rPr lang="en-US"/>
               <a:t>Fourth level</a:t>
             </a:r>
           </a:p>
           <a:p>
             <a:pPr lvl="4"/>
             <a:r>
-              <a:rPr lang="en-US" smtClean="0"/>
+              <a:rPr lang="en-US"/>
               <a:t>Fifth level</a:t>
             </a:r>
-            <a:endParaRPr lang="en-US"/>
           </a:p>
         </p:txBody>
       </p:sp>
@@ -2732,7 +2721,7 @@
           <a:p>
             <a:fld id="{5BCAD085-E8A6-8845-BD4E-CB4CCA059FC4}" type="datetimeFigureOut">
               <a:rPr lang="en-US" smtClean="0"/>
-              <a:t>1/27/13</a:t>
+              <a:t>6/8/2026</a:t>
             </a:fld>
             <a:endParaRPr lang="en-US"/>
           </a:p>
@@ -3091,7 +3080,7 @@
 </file>
 
 <file path=ppt/slides/slide1.xml><?xml version="1.0" encoding="utf-8"?>
-<p:sld xmlns:a="http://schemas.openxmlformats.org/drawingml/2006/main" xmlns:p="http://schemas.openxmlformats.org/presentationml/2006/main" xmlns:r="http://schemas.openxmlformats.org/officeDocument/2006/relationships">
+<p:sld xmlns:a="http://schemas.openxmlformats.org/drawingml/2006/main" xmlns:r="http://schemas.openxmlformats.org/officeDocument/2006/relationships" xmlns:p="http://schemas.openxmlformats.org/presentationml/2006/main">
   <p:cSld>
     <p:spTree>
       <p:nvGrpSpPr>
@@ -3099,7 +3088,14 @@
         <p:cNvGrpSpPr/>
         <p:nvPr/>
       </p:nvGrpSpPr>
-      <p:grpSpPr/>
+      <p:grpSpPr>
+        <a:xfrm>
+          <a:off x="0" y="0"/>
+          <a:ext cx="0" cy="0"/>
+          <a:chOff x="0" y="0"/>
+          <a:chExt cx="0" cy="0"/>
+        </a:xfrm>
+      </p:grpSpPr>
       <p:pic>
         <p:nvPicPr>
           <p:cNvPr id="2" name="Picture 1" descr="slide-001.png"/>
@@ -3164,6 +3160,7 @@
           <a:lstStyle/>
           <a:p>
             <a:pPr algn="ctr"/>
+            <a:endParaRPr/>
           </a:p>
         </p:txBody>
       </p:sp>
@@ -3207,6 +3204,7 @@
           <a:lstStyle/>
           <a:p>
             <a:pPr algn="ctr"/>
+            <a:endParaRPr/>
           </a:p>
         </p:txBody>
       </p:sp>
@@ -3250,6 +3248,7 @@
           <a:lstStyle/>
           <a:p>
             <a:pPr algn="ctr"/>
+            <a:endParaRPr/>
           </a:p>
         </p:txBody>
       </p:sp>
@@ -3293,6 +3292,7 @@
           <a:lstStyle/>
           <a:p>
             <a:pPr algn="ctr"/>
+            <a:endParaRPr/>
           </a:p>
         </p:txBody>
       </p:sp>
@@ -3336,264 +3336,7 @@
           <a:lstStyle/>
           <a:p>
             <a:pPr algn="ctr"/>
-          </a:p>
-        </p:txBody>
-      </p:sp>
-      <p:sp>
-        <p:nvSpPr>
-          <p:cNvPr id="8" name="Rectangle 7">
-            <a:hlinkClick r:id="rId8"/>
-          </p:cNvPr>
-          <p:cNvSpPr/>
-          <p:nvPr/>
-        </p:nvSpPr>
-        <p:spPr>
-          <a:xfrm>
-            <a:off x="10360152" y="3570732"/>
-            <a:ext cx="1143000" cy="182880"/>
-          </a:xfrm>
-          <a:prstGeom prst="rect">
-            <a:avLst/>
-          </a:prstGeom>
-          <a:noFill/>
-          <a:ln>
-            <a:noFill/>
-          </a:ln>
-        </p:spPr>
-        <p:style>
-          <a:lnRef idx="1">
-            <a:schemeClr val="accent1"/>
-          </a:lnRef>
-          <a:fillRef idx="3">
-            <a:schemeClr val="accent1"/>
-          </a:fillRef>
-          <a:effectRef idx="2">
-            <a:schemeClr val="accent1"/>
-          </a:effectRef>
-          <a:fontRef idx="minor">
-            <a:schemeClr val="lt1"/>
-          </a:fontRef>
-        </p:style>
-        <p:txBody>
-          <a:bodyPr rtlCol="0" anchor="ctr"/>
-          <a:lstStyle/>
-          <a:p>
-            <a:pPr algn="ctr"/>
-          </a:p>
-        </p:txBody>
-      </p:sp>
-      <p:sp>
-        <p:nvSpPr>
-          <p:cNvPr id="9" name="Rectangle 8">
-            <a:hlinkClick r:id="rId9"/>
-          </p:cNvPr>
-          <p:cNvSpPr/>
-          <p:nvPr/>
-        </p:nvSpPr>
-        <p:spPr>
-          <a:xfrm>
-            <a:off x="10360152" y="3776472"/>
-            <a:ext cx="1143000" cy="182880"/>
-          </a:xfrm>
-          <a:prstGeom prst="rect">
-            <a:avLst/>
-          </a:prstGeom>
-          <a:noFill/>
-          <a:ln>
-            <a:noFill/>
-          </a:ln>
-        </p:spPr>
-        <p:style>
-          <a:lnRef idx="1">
-            <a:schemeClr val="accent1"/>
-          </a:lnRef>
-          <a:fillRef idx="3">
-            <a:schemeClr val="accent1"/>
-          </a:fillRef>
-          <a:effectRef idx="2">
-            <a:schemeClr val="accent1"/>
-          </a:effectRef>
-          <a:fontRef idx="minor">
-            <a:schemeClr val="lt1"/>
-          </a:fontRef>
-        </p:style>
-        <p:txBody>
-          <a:bodyPr rtlCol="0" anchor="ctr"/>
-          <a:lstStyle/>
-          <a:p>
-            <a:pPr algn="ctr"/>
-          </a:p>
-        </p:txBody>
-      </p:sp>
-      <p:sp>
-        <p:nvSpPr>
-          <p:cNvPr id="10" name="Rectangle 9">
-            <a:hlinkClick r:id="rId10"/>
-          </p:cNvPr>
-          <p:cNvSpPr/>
-          <p:nvPr/>
-        </p:nvSpPr>
-        <p:spPr>
-          <a:xfrm>
-            <a:off x="10360152" y="3982211"/>
-            <a:ext cx="1143000" cy="182880"/>
-          </a:xfrm>
-          <a:prstGeom prst="rect">
-            <a:avLst/>
-          </a:prstGeom>
-          <a:noFill/>
-          <a:ln>
-            <a:noFill/>
-          </a:ln>
-        </p:spPr>
-        <p:style>
-          <a:lnRef idx="1">
-            <a:schemeClr val="accent1"/>
-          </a:lnRef>
-          <a:fillRef idx="3">
-            <a:schemeClr val="accent1"/>
-          </a:fillRef>
-          <a:effectRef idx="2">
-            <a:schemeClr val="accent1"/>
-          </a:effectRef>
-          <a:fontRef idx="minor">
-            <a:schemeClr val="lt1"/>
-          </a:fontRef>
-        </p:style>
-        <p:txBody>
-          <a:bodyPr rtlCol="0" anchor="ctr"/>
-          <a:lstStyle/>
-          <a:p>
-            <a:pPr algn="ctr"/>
-          </a:p>
-        </p:txBody>
-      </p:sp>
-      <p:sp>
-        <p:nvSpPr>
-          <p:cNvPr id="11" name="Rectangle 10">
-            <a:hlinkClick r:id="rId11"/>
-          </p:cNvPr>
-          <p:cNvSpPr/>
-          <p:nvPr/>
-        </p:nvSpPr>
-        <p:spPr>
-          <a:xfrm>
-            <a:off x="10360152" y="4187952"/>
-            <a:ext cx="1143000" cy="182880"/>
-          </a:xfrm>
-          <a:prstGeom prst="rect">
-            <a:avLst/>
-          </a:prstGeom>
-          <a:noFill/>
-          <a:ln>
-            <a:noFill/>
-          </a:ln>
-        </p:spPr>
-        <p:style>
-          <a:lnRef idx="1">
-            <a:schemeClr val="accent1"/>
-          </a:lnRef>
-          <a:fillRef idx="3">
-            <a:schemeClr val="accent1"/>
-          </a:fillRef>
-          <a:effectRef idx="2">
-            <a:schemeClr val="accent1"/>
-          </a:effectRef>
-          <a:fontRef idx="minor">
-            <a:schemeClr val="lt1"/>
-          </a:fontRef>
-        </p:style>
-        <p:txBody>
-          <a:bodyPr rtlCol="0" anchor="ctr"/>
-          <a:lstStyle/>
-          <a:p>
-            <a:pPr algn="ctr"/>
-          </a:p>
-        </p:txBody>
-      </p:sp>
-      <p:sp>
-        <p:nvSpPr>
-          <p:cNvPr id="12" name="Rectangle 11">
-            <a:hlinkClick r:id="rId12"/>
-          </p:cNvPr>
-          <p:cNvSpPr/>
-          <p:nvPr/>
-        </p:nvSpPr>
-        <p:spPr>
-          <a:xfrm>
-            <a:off x="10360152" y="4393692"/>
-            <a:ext cx="1143000" cy="182880"/>
-          </a:xfrm>
-          <a:prstGeom prst="rect">
-            <a:avLst/>
-          </a:prstGeom>
-          <a:noFill/>
-          <a:ln>
-            <a:noFill/>
-          </a:ln>
-        </p:spPr>
-        <p:style>
-          <a:lnRef idx="1">
-            <a:schemeClr val="accent1"/>
-          </a:lnRef>
-          <a:fillRef idx="3">
-            <a:schemeClr val="accent1"/>
-          </a:fillRef>
-          <a:effectRef idx="2">
-            <a:schemeClr val="accent1"/>
-          </a:effectRef>
-          <a:fontRef idx="minor">
-            <a:schemeClr val="lt1"/>
-          </a:fontRef>
-        </p:style>
-        <p:txBody>
-          <a:bodyPr rtlCol="0" anchor="ctr"/>
-          <a:lstStyle/>
-          <a:p>
-            <a:pPr algn="ctr"/>
-          </a:p>
-        </p:txBody>
-      </p:sp>
-      <p:sp>
-        <p:nvSpPr>
-          <p:cNvPr id="13" name="Rectangle 12">
-            <a:hlinkClick r:id="rId13"/>
-          </p:cNvPr>
-          <p:cNvSpPr/>
-          <p:nvPr/>
-        </p:nvSpPr>
-        <p:spPr>
-          <a:xfrm>
-            <a:off x="10360152" y="4599431"/>
-            <a:ext cx="1143000" cy="182880"/>
-          </a:xfrm>
-          <a:prstGeom prst="rect">
-            <a:avLst/>
-          </a:prstGeom>
-          <a:noFill/>
-          <a:ln>
-            <a:noFill/>
-          </a:ln>
-        </p:spPr>
-        <p:style>
-          <a:lnRef idx="1">
-            <a:schemeClr val="accent1"/>
-          </a:lnRef>
-          <a:fillRef idx="3">
-            <a:schemeClr val="accent1"/>
-          </a:fillRef>
-          <a:effectRef idx="2">
-            <a:schemeClr val="accent1"/>
-          </a:effectRef>
-          <a:fontRef idx="minor">
-            <a:schemeClr val="lt1"/>
-          </a:fontRef>
-        </p:style>
-        <p:txBody>
-          <a:bodyPr rtlCol="0" anchor="ctr"/>
-          <a:lstStyle/>
-          <a:p>
-            <a:pPr algn="ctr"/>
+            <a:endParaRPr/>
           </a:p>
         </p:txBody>
       </p:sp>
@@ -3605,8 +3348,8 @@
 </p:sld>
 </file>
 
-<file path=ppt/slides/slide10.xml><?xml version="1.0" encoding="utf-8"?>
-<p:sld xmlns:a="http://schemas.openxmlformats.org/drawingml/2006/main" xmlns:p="http://schemas.openxmlformats.org/presentationml/2006/main" xmlns:r="http://schemas.openxmlformats.org/officeDocument/2006/relationships">
+<file path=ppt/slides/slide2.xml><?xml version="1.0" encoding="utf-8"?>
+<p:sld xmlns:a="http://schemas.openxmlformats.org/drawingml/2006/main" xmlns:r="http://schemas.openxmlformats.org/officeDocument/2006/relationships" xmlns:p="http://schemas.openxmlformats.org/presentationml/2006/main">
   <p:cSld>
     <p:spTree>
       <p:nvGrpSpPr>
@@ -3614,10 +3357,17 @@
         <p:cNvGrpSpPr/>
         <p:nvPr/>
       </p:nvGrpSpPr>
-      <p:grpSpPr/>
+      <p:grpSpPr>
+        <a:xfrm>
+          <a:off x="0" y="0"/>
+          <a:ext cx="0" cy="0"/>
+          <a:chOff x="0" y="0"/>
+          <a:chExt cx="0" cy="0"/>
+        </a:xfrm>
+      </p:grpSpPr>
       <p:pic>
         <p:nvPicPr>
-          <p:cNvPr id="2" name="Picture 1" descr="slide-010.png"/>
+          <p:cNvPr id="2" name="Picture 1" descr="slide-002.png"/>
           <p:cNvPicPr>
             <a:picLocks noChangeAspect="1"/>
           </p:cNvPicPr>
@@ -3679,6 +3429,7 @@
           <a:lstStyle/>
           <a:p>
             <a:pPr algn="ctr"/>
+            <a:endParaRPr/>
           </a:p>
         </p:txBody>
       </p:sp>
@@ -3722,6 +3473,7 @@
           <a:lstStyle/>
           <a:p>
             <a:pPr algn="ctr"/>
+            <a:endParaRPr/>
           </a:p>
         </p:txBody>
       </p:sp>
@@ -3733,8 +3485,8 @@
 </p:sld>
 </file>
 
-<file path=ppt/slides/slide11.xml><?xml version="1.0" encoding="utf-8"?>
-<p:sld xmlns:a="http://schemas.openxmlformats.org/drawingml/2006/main" xmlns:p="http://schemas.openxmlformats.org/presentationml/2006/main" xmlns:r="http://schemas.openxmlformats.org/officeDocument/2006/relationships">
+<file path=ppt/slides/slide3.xml><?xml version="1.0" encoding="utf-8"?>
+<p:sld xmlns:a="http://schemas.openxmlformats.org/drawingml/2006/main" xmlns:r="http://schemas.openxmlformats.org/officeDocument/2006/relationships" xmlns:p="http://schemas.openxmlformats.org/presentationml/2006/main">
   <p:cSld>
     <p:spTree>
       <p:nvGrpSpPr>
@@ -3742,10 +3494,17 @@
         <p:cNvGrpSpPr/>
         <p:nvPr/>
       </p:nvGrpSpPr>
-      <p:grpSpPr/>
+      <p:grpSpPr>
+        <a:xfrm>
+          <a:off x="0" y="0"/>
+          <a:ext cx="0" cy="0"/>
+          <a:chOff x="0" y="0"/>
+          <a:chExt cx="0" cy="0"/>
+        </a:xfrm>
+      </p:grpSpPr>
       <p:pic>
         <p:nvPicPr>
-          <p:cNvPr id="2" name="Picture 1" descr="slide-011.png"/>
+          <p:cNvPr id="2" name="Picture 1" descr="slide-003.png"/>
           <p:cNvPicPr>
             <a:picLocks noChangeAspect="1"/>
           </p:cNvPicPr>
@@ -3807,6 +3566,7 @@
           <a:lstStyle/>
           <a:p>
             <a:pPr algn="ctr"/>
+            <a:endParaRPr/>
           </a:p>
         </p:txBody>
       </p:sp>
@@ -3850,6 +3610,7 @@
           <a:lstStyle/>
           <a:p>
             <a:pPr algn="ctr"/>
+            <a:endParaRPr/>
           </a:p>
         </p:txBody>
       </p:sp>
@@ -3861,8 +3622,8 @@
 </p:sld>
 </file>
 
-<file path=ppt/slides/slide12.xml><?xml version="1.0" encoding="utf-8"?>
-<p:sld xmlns:a="http://schemas.openxmlformats.org/drawingml/2006/main" xmlns:p="http://schemas.openxmlformats.org/presentationml/2006/main" xmlns:r="http://schemas.openxmlformats.org/officeDocument/2006/relationships">
+<file path=ppt/slides/slide4.xml><?xml version="1.0" encoding="utf-8"?>
+<p:sld xmlns:a="http://schemas.openxmlformats.org/drawingml/2006/main" xmlns:r="http://schemas.openxmlformats.org/officeDocument/2006/relationships" xmlns:p="http://schemas.openxmlformats.org/presentationml/2006/main">
   <p:cSld>
     <p:spTree>
       <p:nvGrpSpPr>
@@ -3870,10 +3631,17 @@
         <p:cNvGrpSpPr/>
         <p:nvPr/>
       </p:nvGrpSpPr>
-      <p:grpSpPr/>
+      <p:grpSpPr>
+        <a:xfrm>
+          <a:off x="0" y="0"/>
+          <a:ext cx="0" cy="0"/>
+          <a:chOff x="0" y="0"/>
+          <a:chExt cx="0" cy="0"/>
+        </a:xfrm>
+      </p:grpSpPr>
       <p:pic>
         <p:nvPicPr>
-          <p:cNvPr id="2" name="Picture 1" descr="slide-012.png"/>
+          <p:cNvPr id="2" name="Picture 1" descr="slide-004.png"/>
           <p:cNvPicPr>
             <a:picLocks noChangeAspect="1"/>
           </p:cNvPicPr>
@@ -3935,6 +3703,7 @@
           <a:lstStyle/>
           <a:p>
             <a:pPr algn="ctr"/>
+            <a:endParaRPr/>
           </a:p>
         </p:txBody>
       </p:sp>
@@ -3978,6 +3747,7 @@
           <a:lstStyle/>
           <a:p>
             <a:pPr algn="ctr"/>
+            <a:endParaRPr/>
           </a:p>
         </p:txBody>
       </p:sp>
@@ -3989,8 +3759,8 @@
 </p:sld>
 </file>
 
-<file path=ppt/slides/slide13.xml><?xml version="1.0" encoding="utf-8"?>
-<p:sld xmlns:a="http://schemas.openxmlformats.org/drawingml/2006/main" xmlns:p="http://schemas.openxmlformats.org/presentationml/2006/main" xmlns:r="http://schemas.openxmlformats.org/officeDocument/2006/relationships">
+<file path=ppt/slides/slide5.xml><?xml version="1.0" encoding="utf-8"?>
+<p:sld xmlns:a="http://schemas.openxmlformats.org/drawingml/2006/main" xmlns:r="http://schemas.openxmlformats.org/officeDocument/2006/relationships" xmlns:p="http://schemas.openxmlformats.org/presentationml/2006/main">
   <p:cSld>
     <p:spTree>
       <p:nvGrpSpPr>
@@ -3998,52 +3768,17 @@
         <p:cNvGrpSpPr/>
         <p:nvPr/>
       </p:nvGrpSpPr>
-      <p:grpSpPr/>
+      <p:grpSpPr>
+        <a:xfrm>
+          <a:off x="0" y="0"/>
+          <a:ext cx="0" cy="0"/>
+          <a:chOff x="0" y="0"/>
+          <a:chExt cx="0" cy="0"/>
+        </a:xfrm>
+      </p:grpSpPr>
       <p:pic>
         <p:nvPicPr>
-          <p:cNvPr id="2" name="Picture 1" descr="slide-013.png"/>
-          <p:cNvPicPr>
-            <a:picLocks noChangeAspect="1"/>
-          </p:cNvPicPr>
-          <p:nvPr/>
-        </p:nvPicPr>
-        <p:blipFill>
-          <a:blip r:embed="rId2"/>
-          <a:stretch>
-            <a:fillRect/>
-          </a:stretch>
-        </p:blipFill>
-        <p:spPr>
-          <a:xfrm>
-            <a:off x="0" y="0"/>
-            <a:ext cx="12191999" cy="6858000"/>
-          </a:xfrm>
-          <a:prstGeom prst="rect">
-            <a:avLst/>
-          </a:prstGeom>
-        </p:spPr>
-      </p:pic>
-    </p:spTree>
-  </p:cSld>
-  <p:clrMapOvr>
-    <a:masterClrMapping/>
-  </p:clrMapOvr>
-</p:sld>
-</file>
-
-<file path=ppt/slides/slide2.xml><?xml version="1.0" encoding="utf-8"?>
-<p:sld xmlns:a="http://schemas.openxmlformats.org/drawingml/2006/main" xmlns:p="http://schemas.openxmlformats.org/presentationml/2006/main" xmlns:r="http://schemas.openxmlformats.org/officeDocument/2006/relationships">
-  <p:cSld>
-    <p:spTree>
-      <p:nvGrpSpPr>
-        <p:cNvPr id="1" name=""/>
-        <p:cNvGrpSpPr/>
-        <p:nvPr/>
-      </p:nvGrpSpPr>
-      <p:grpSpPr/>
-      <p:pic>
-        <p:nvPicPr>
-          <p:cNvPr id="2" name="Picture 1" descr="slide-002.png"/>
+          <p:cNvPr id="2" name="Picture 1" descr="slide-005.png"/>
           <p:cNvPicPr>
             <a:picLocks noChangeAspect="1"/>
           </p:cNvPicPr>
@@ -4105,6 +3840,7 @@
           <a:lstStyle/>
           <a:p>
             <a:pPr algn="ctr"/>
+            <a:endParaRPr/>
           </a:p>
         </p:txBody>
       </p:sp>
@@ -4148,6 +3884,7 @@
           <a:lstStyle/>
           <a:p>
             <a:pPr algn="ctr"/>
+            <a:endParaRPr/>
           </a:p>
         </p:txBody>
       </p:sp>
@@ -4159,8 +3896,8 @@
 </p:sld>
 </file>
 
-<file path=ppt/slides/slide3.xml><?xml version="1.0" encoding="utf-8"?>
-<p:sld xmlns:a="http://schemas.openxmlformats.org/drawingml/2006/main" xmlns:p="http://schemas.openxmlformats.org/presentationml/2006/main" xmlns:r="http://schemas.openxmlformats.org/officeDocument/2006/relationships">
+<file path=ppt/slides/slide6.xml><?xml version="1.0" encoding="utf-8"?>
+<p:sld xmlns:a="http://schemas.openxmlformats.org/drawingml/2006/main" xmlns:r="http://schemas.openxmlformats.org/officeDocument/2006/relationships" xmlns:p="http://schemas.openxmlformats.org/presentationml/2006/main">
   <p:cSld>
     <p:spTree>
       <p:nvGrpSpPr>
@@ -4168,10 +3905,17 @@
         <p:cNvGrpSpPr/>
         <p:nvPr/>
       </p:nvGrpSpPr>
-      <p:grpSpPr/>
+      <p:grpSpPr>
+        <a:xfrm>
+          <a:off x="0" y="0"/>
+          <a:ext cx="0" cy="0"/>
+          <a:chOff x="0" y="0"/>
+          <a:chExt cx="0" cy="0"/>
+        </a:xfrm>
+      </p:grpSpPr>
       <p:pic>
         <p:nvPicPr>
-          <p:cNvPr id="2" name="Picture 1" descr="slide-003.png"/>
+          <p:cNvPr id="2" name="Picture 1" descr="slide-006.png"/>
           <p:cNvPicPr>
             <a:picLocks noChangeAspect="1"/>
           </p:cNvPicPr>
@@ -4233,6 +3977,7 @@
           <a:lstStyle/>
           <a:p>
             <a:pPr algn="ctr"/>
+            <a:endParaRPr/>
           </a:p>
         </p:txBody>
       </p:sp>
@@ -4276,390 +4021,7 @@
           <a:lstStyle/>
           <a:p>
             <a:pPr algn="ctr"/>
-          </a:p>
-        </p:txBody>
-      </p:sp>
-    </p:spTree>
-  </p:cSld>
-  <p:clrMapOvr>
-    <a:masterClrMapping/>
-  </p:clrMapOvr>
-</p:sld>
-</file>
-
-<file path=ppt/slides/slide4.xml><?xml version="1.0" encoding="utf-8"?>
-<p:sld xmlns:a="http://schemas.openxmlformats.org/drawingml/2006/main" xmlns:p="http://schemas.openxmlformats.org/presentationml/2006/main" xmlns:r="http://schemas.openxmlformats.org/officeDocument/2006/relationships">
-  <p:cSld>
-    <p:spTree>
-      <p:nvGrpSpPr>
-        <p:cNvPr id="1" name=""/>
-        <p:cNvGrpSpPr/>
-        <p:nvPr/>
-      </p:nvGrpSpPr>
-      <p:grpSpPr/>
-      <p:pic>
-        <p:nvPicPr>
-          <p:cNvPr id="2" name="Picture 1" descr="slide-004.png"/>
-          <p:cNvPicPr>
-            <a:picLocks noChangeAspect="1"/>
-          </p:cNvPicPr>
-          <p:nvPr/>
-        </p:nvPicPr>
-        <p:blipFill>
-          <a:blip r:embed="rId2"/>
-          <a:stretch>
-            <a:fillRect/>
-          </a:stretch>
-        </p:blipFill>
-        <p:spPr>
-          <a:xfrm>
-            <a:off x="0" y="0"/>
-            <a:ext cx="12191999" cy="6858000"/>
-          </a:xfrm>
-          <a:prstGeom prst="rect">
-            <a:avLst/>
-          </a:prstGeom>
-        </p:spPr>
-      </p:pic>
-      <p:sp>
-        <p:nvSpPr>
-          <p:cNvPr id="3" name="Rectangle 2">
-            <a:hlinkClick r:id="rId3"/>
-          </p:cNvPr>
-          <p:cNvSpPr/>
-          <p:nvPr/>
-        </p:nvSpPr>
-        <p:spPr>
-          <a:xfrm>
-            <a:off x="9509760" y="384048"/>
-            <a:ext cx="1828800" cy="310896"/>
-          </a:xfrm>
-          <a:prstGeom prst="rect">
-            <a:avLst/>
-          </a:prstGeom>
-          <a:noFill/>
-          <a:ln>
-            <a:noFill/>
-          </a:ln>
-        </p:spPr>
-        <p:style>
-          <a:lnRef idx="1">
-            <a:schemeClr val="accent1"/>
-          </a:lnRef>
-          <a:fillRef idx="3">
-            <a:schemeClr val="accent1"/>
-          </a:fillRef>
-          <a:effectRef idx="2">
-            <a:schemeClr val="accent1"/>
-          </a:effectRef>
-          <a:fontRef idx="minor">
-            <a:schemeClr val="lt1"/>
-          </a:fontRef>
-        </p:style>
-        <p:txBody>
-          <a:bodyPr rtlCol="0" anchor="ctr"/>
-          <a:lstStyle/>
-          <a:p>
-            <a:pPr algn="ctr"/>
-          </a:p>
-        </p:txBody>
-      </p:sp>
-      <p:sp>
-        <p:nvSpPr>
-          <p:cNvPr id="4" name="Rectangle 3">
-            <a:hlinkClick r:id="rId3"/>
-          </p:cNvPr>
-          <p:cNvSpPr/>
-          <p:nvPr/>
-        </p:nvSpPr>
-        <p:spPr>
-          <a:xfrm>
-            <a:off x="6400800" y="6473952"/>
-            <a:ext cx="4937760" cy="201168"/>
-          </a:xfrm>
-          <a:prstGeom prst="rect">
-            <a:avLst/>
-          </a:prstGeom>
-          <a:noFill/>
-          <a:ln>
-            <a:noFill/>
-          </a:ln>
-        </p:spPr>
-        <p:style>
-          <a:lnRef idx="1">
-            <a:schemeClr val="accent1"/>
-          </a:lnRef>
-          <a:fillRef idx="3">
-            <a:schemeClr val="accent1"/>
-          </a:fillRef>
-          <a:effectRef idx="2">
-            <a:schemeClr val="accent1"/>
-          </a:effectRef>
-          <a:fontRef idx="minor">
-            <a:schemeClr val="lt1"/>
-          </a:fontRef>
-        </p:style>
-        <p:txBody>
-          <a:bodyPr rtlCol="0" anchor="ctr"/>
-          <a:lstStyle/>
-          <a:p>
-            <a:pPr algn="ctr"/>
-          </a:p>
-        </p:txBody>
-      </p:sp>
-    </p:spTree>
-  </p:cSld>
-  <p:clrMapOvr>
-    <a:masterClrMapping/>
-  </p:clrMapOvr>
-</p:sld>
-</file>
-
-<file path=ppt/slides/slide5.xml><?xml version="1.0" encoding="utf-8"?>
-<p:sld xmlns:a="http://schemas.openxmlformats.org/drawingml/2006/main" xmlns:p="http://schemas.openxmlformats.org/presentationml/2006/main" xmlns:r="http://schemas.openxmlformats.org/officeDocument/2006/relationships">
-  <p:cSld>
-    <p:spTree>
-      <p:nvGrpSpPr>
-        <p:cNvPr id="1" name=""/>
-        <p:cNvGrpSpPr/>
-        <p:nvPr/>
-      </p:nvGrpSpPr>
-      <p:grpSpPr/>
-      <p:pic>
-        <p:nvPicPr>
-          <p:cNvPr id="2" name="Picture 1" descr="slide-005.png"/>
-          <p:cNvPicPr>
-            <a:picLocks noChangeAspect="1"/>
-          </p:cNvPicPr>
-          <p:nvPr/>
-        </p:nvPicPr>
-        <p:blipFill>
-          <a:blip r:embed="rId2"/>
-          <a:stretch>
-            <a:fillRect/>
-          </a:stretch>
-        </p:blipFill>
-        <p:spPr>
-          <a:xfrm>
-            <a:off x="0" y="0"/>
-            <a:ext cx="12191999" cy="6858000"/>
-          </a:xfrm>
-          <a:prstGeom prst="rect">
-            <a:avLst/>
-          </a:prstGeom>
-        </p:spPr>
-      </p:pic>
-      <p:sp>
-        <p:nvSpPr>
-          <p:cNvPr id="3" name="Rectangle 2">
-            <a:hlinkClick r:id="rId3"/>
-          </p:cNvPr>
-          <p:cNvSpPr/>
-          <p:nvPr/>
-        </p:nvSpPr>
-        <p:spPr>
-          <a:xfrm>
-            <a:off x="9509760" y="384048"/>
-            <a:ext cx="1828800" cy="310896"/>
-          </a:xfrm>
-          <a:prstGeom prst="rect">
-            <a:avLst/>
-          </a:prstGeom>
-          <a:noFill/>
-          <a:ln>
-            <a:noFill/>
-          </a:ln>
-        </p:spPr>
-        <p:style>
-          <a:lnRef idx="1">
-            <a:schemeClr val="accent1"/>
-          </a:lnRef>
-          <a:fillRef idx="3">
-            <a:schemeClr val="accent1"/>
-          </a:fillRef>
-          <a:effectRef idx="2">
-            <a:schemeClr val="accent1"/>
-          </a:effectRef>
-          <a:fontRef idx="minor">
-            <a:schemeClr val="lt1"/>
-          </a:fontRef>
-        </p:style>
-        <p:txBody>
-          <a:bodyPr rtlCol="0" anchor="ctr"/>
-          <a:lstStyle/>
-          <a:p>
-            <a:pPr algn="ctr"/>
-          </a:p>
-        </p:txBody>
-      </p:sp>
-      <p:sp>
-        <p:nvSpPr>
-          <p:cNvPr id="4" name="Rectangle 3">
-            <a:hlinkClick r:id="rId3"/>
-          </p:cNvPr>
-          <p:cNvSpPr/>
-          <p:nvPr/>
-        </p:nvSpPr>
-        <p:spPr>
-          <a:xfrm>
-            <a:off x="6400800" y="6473952"/>
-            <a:ext cx="4937760" cy="201168"/>
-          </a:xfrm>
-          <a:prstGeom prst="rect">
-            <a:avLst/>
-          </a:prstGeom>
-          <a:noFill/>
-          <a:ln>
-            <a:noFill/>
-          </a:ln>
-        </p:spPr>
-        <p:style>
-          <a:lnRef idx="1">
-            <a:schemeClr val="accent1"/>
-          </a:lnRef>
-          <a:fillRef idx="3">
-            <a:schemeClr val="accent1"/>
-          </a:fillRef>
-          <a:effectRef idx="2">
-            <a:schemeClr val="accent1"/>
-          </a:effectRef>
-          <a:fontRef idx="minor">
-            <a:schemeClr val="lt1"/>
-          </a:fontRef>
-        </p:style>
-        <p:txBody>
-          <a:bodyPr rtlCol="0" anchor="ctr"/>
-          <a:lstStyle/>
-          <a:p>
-            <a:pPr algn="ctr"/>
-          </a:p>
-        </p:txBody>
-      </p:sp>
-    </p:spTree>
-  </p:cSld>
-  <p:clrMapOvr>
-    <a:masterClrMapping/>
-  </p:clrMapOvr>
-</p:sld>
-</file>
-
-<file path=ppt/slides/slide6.xml><?xml version="1.0" encoding="utf-8"?>
-<p:sld xmlns:a="http://schemas.openxmlformats.org/drawingml/2006/main" xmlns:p="http://schemas.openxmlformats.org/presentationml/2006/main" xmlns:r="http://schemas.openxmlformats.org/officeDocument/2006/relationships">
-  <p:cSld>
-    <p:spTree>
-      <p:nvGrpSpPr>
-        <p:cNvPr id="1" name=""/>
-        <p:cNvGrpSpPr/>
-        <p:nvPr/>
-      </p:nvGrpSpPr>
-      <p:grpSpPr/>
-      <p:pic>
-        <p:nvPicPr>
-          <p:cNvPr id="2" name="Picture 1" descr="slide-006.png"/>
-          <p:cNvPicPr>
-            <a:picLocks noChangeAspect="1"/>
-          </p:cNvPicPr>
-          <p:nvPr/>
-        </p:nvPicPr>
-        <p:blipFill>
-          <a:blip r:embed="rId2"/>
-          <a:stretch>
-            <a:fillRect/>
-          </a:stretch>
-        </p:blipFill>
-        <p:spPr>
-          <a:xfrm>
-            <a:off x="0" y="0"/>
-            <a:ext cx="12191999" cy="6858000"/>
-          </a:xfrm>
-          <a:prstGeom prst="rect">
-            <a:avLst/>
-          </a:prstGeom>
-        </p:spPr>
-      </p:pic>
-      <p:sp>
-        <p:nvSpPr>
-          <p:cNvPr id="3" name="Rectangle 2">
-            <a:hlinkClick r:id="rId3"/>
-          </p:cNvPr>
-          <p:cNvSpPr/>
-          <p:nvPr/>
-        </p:nvSpPr>
-        <p:spPr>
-          <a:xfrm>
-            <a:off x="9509760" y="384048"/>
-            <a:ext cx="1828800" cy="310896"/>
-          </a:xfrm>
-          <a:prstGeom prst="rect">
-            <a:avLst/>
-          </a:prstGeom>
-          <a:noFill/>
-          <a:ln>
-            <a:noFill/>
-          </a:ln>
-        </p:spPr>
-        <p:style>
-          <a:lnRef idx="1">
-            <a:schemeClr val="accent1"/>
-          </a:lnRef>
-          <a:fillRef idx="3">
-            <a:schemeClr val="accent1"/>
-          </a:fillRef>
-          <a:effectRef idx="2">
-            <a:schemeClr val="accent1"/>
-          </a:effectRef>
-          <a:fontRef idx="minor">
-            <a:schemeClr val="lt1"/>
-          </a:fontRef>
-        </p:style>
-        <p:txBody>
-          <a:bodyPr rtlCol="0" anchor="ctr"/>
-          <a:lstStyle/>
-          <a:p>
-            <a:pPr algn="ctr"/>
-          </a:p>
-        </p:txBody>
-      </p:sp>
-      <p:sp>
-        <p:nvSpPr>
-          <p:cNvPr id="4" name="Rectangle 3">
-            <a:hlinkClick r:id="rId3"/>
-          </p:cNvPr>
-          <p:cNvSpPr/>
-          <p:nvPr/>
-        </p:nvSpPr>
-        <p:spPr>
-          <a:xfrm>
-            <a:off x="6400800" y="6473952"/>
-            <a:ext cx="4937760" cy="201168"/>
-          </a:xfrm>
-          <a:prstGeom prst="rect">
-            <a:avLst/>
-          </a:prstGeom>
-          <a:noFill/>
-          <a:ln>
-            <a:noFill/>
-          </a:ln>
-        </p:spPr>
-        <p:style>
-          <a:lnRef idx="1">
-            <a:schemeClr val="accent1"/>
-          </a:lnRef>
-          <a:fillRef idx="3">
-            <a:schemeClr val="accent1"/>
-          </a:fillRef>
-          <a:effectRef idx="2">
-            <a:schemeClr val="accent1"/>
-          </a:effectRef>
-          <a:fontRef idx="minor">
-            <a:schemeClr val="lt1"/>
-          </a:fontRef>
-        </p:style>
-        <p:txBody>
-          <a:bodyPr rtlCol="0" anchor="ctr"/>
-          <a:lstStyle/>
-          <a:p>
-            <a:pPr algn="ctr"/>
+            <a:endParaRPr/>
           </a:p>
         </p:txBody>
       </p:sp>
@@ -4672,7 +4034,7 @@
 </file>
 
 <file path=ppt/slides/slide7.xml><?xml version="1.0" encoding="utf-8"?>
-<p:sld xmlns:a="http://schemas.openxmlformats.org/drawingml/2006/main" xmlns:p="http://schemas.openxmlformats.org/presentationml/2006/main" xmlns:r="http://schemas.openxmlformats.org/officeDocument/2006/relationships">
+<p:sld xmlns:a="http://schemas.openxmlformats.org/drawingml/2006/main" xmlns:r="http://schemas.openxmlformats.org/officeDocument/2006/relationships" xmlns:p="http://schemas.openxmlformats.org/presentationml/2006/main">
   <p:cSld>
     <p:spTree>
       <p:nvGrpSpPr>
@@ -4680,7 +4042,14 @@
         <p:cNvGrpSpPr/>
         <p:nvPr/>
       </p:nvGrpSpPr>
-      <p:grpSpPr/>
+      <p:grpSpPr>
+        <a:xfrm>
+          <a:off x="0" y="0"/>
+          <a:ext cx="0" cy="0"/>
+          <a:chOff x="0" y="0"/>
+          <a:chExt cx="0" cy="0"/>
+        </a:xfrm>
+      </p:grpSpPr>
       <p:pic>
         <p:nvPicPr>
           <p:cNvPr id="2" name="Picture 1" descr="slide-007.png"/>
@@ -4705,348 +4074,6 @@
           </a:prstGeom>
         </p:spPr>
       </p:pic>
-      <p:sp>
-        <p:nvSpPr>
-          <p:cNvPr id="3" name="Rectangle 2">
-            <a:hlinkClick r:id="rId3"/>
-          </p:cNvPr>
-          <p:cNvSpPr/>
-          <p:nvPr/>
-        </p:nvSpPr>
-        <p:spPr>
-          <a:xfrm>
-            <a:off x="9509760" y="384048"/>
-            <a:ext cx="1828800" cy="310896"/>
-          </a:xfrm>
-          <a:prstGeom prst="rect">
-            <a:avLst/>
-          </a:prstGeom>
-          <a:noFill/>
-          <a:ln>
-            <a:noFill/>
-          </a:ln>
-        </p:spPr>
-        <p:style>
-          <a:lnRef idx="1">
-            <a:schemeClr val="accent1"/>
-          </a:lnRef>
-          <a:fillRef idx="3">
-            <a:schemeClr val="accent1"/>
-          </a:fillRef>
-          <a:effectRef idx="2">
-            <a:schemeClr val="accent1"/>
-          </a:effectRef>
-          <a:fontRef idx="minor">
-            <a:schemeClr val="lt1"/>
-          </a:fontRef>
-        </p:style>
-        <p:txBody>
-          <a:bodyPr rtlCol="0" anchor="ctr"/>
-          <a:lstStyle/>
-          <a:p>
-            <a:pPr algn="ctr"/>
-          </a:p>
-        </p:txBody>
-      </p:sp>
-      <p:sp>
-        <p:nvSpPr>
-          <p:cNvPr id="4" name="Rectangle 3">
-            <a:hlinkClick r:id="rId3"/>
-          </p:cNvPr>
-          <p:cNvSpPr/>
-          <p:nvPr/>
-        </p:nvSpPr>
-        <p:spPr>
-          <a:xfrm>
-            <a:off x="6400800" y="6473952"/>
-            <a:ext cx="4937760" cy="201168"/>
-          </a:xfrm>
-          <a:prstGeom prst="rect">
-            <a:avLst/>
-          </a:prstGeom>
-          <a:noFill/>
-          <a:ln>
-            <a:noFill/>
-          </a:ln>
-        </p:spPr>
-        <p:style>
-          <a:lnRef idx="1">
-            <a:schemeClr val="accent1"/>
-          </a:lnRef>
-          <a:fillRef idx="3">
-            <a:schemeClr val="accent1"/>
-          </a:fillRef>
-          <a:effectRef idx="2">
-            <a:schemeClr val="accent1"/>
-          </a:effectRef>
-          <a:fontRef idx="minor">
-            <a:schemeClr val="lt1"/>
-          </a:fontRef>
-        </p:style>
-        <p:txBody>
-          <a:bodyPr rtlCol="0" anchor="ctr"/>
-          <a:lstStyle/>
-          <a:p>
-            <a:pPr algn="ctr"/>
-          </a:p>
-        </p:txBody>
-      </p:sp>
-    </p:spTree>
-  </p:cSld>
-  <p:clrMapOvr>
-    <a:masterClrMapping/>
-  </p:clrMapOvr>
-</p:sld>
-</file>
-
-<file path=ppt/slides/slide8.xml><?xml version="1.0" encoding="utf-8"?>
-<p:sld xmlns:a="http://schemas.openxmlformats.org/drawingml/2006/main" xmlns:p="http://schemas.openxmlformats.org/presentationml/2006/main" xmlns:r="http://schemas.openxmlformats.org/officeDocument/2006/relationships">
-  <p:cSld>
-    <p:spTree>
-      <p:nvGrpSpPr>
-        <p:cNvPr id="1" name=""/>
-        <p:cNvGrpSpPr/>
-        <p:nvPr/>
-      </p:nvGrpSpPr>
-      <p:grpSpPr/>
-      <p:pic>
-        <p:nvPicPr>
-          <p:cNvPr id="2" name="Picture 1" descr="slide-008.png"/>
-          <p:cNvPicPr>
-            <a:picLocks noChangeAspect="1"/>
-          </p:cNvPicPr>
-          <p:nvPr/>
-        </p:nvPicPr>
-        <p:blipFill>
-          <a:blip r:embed="rId2"/>
-          <a:stretch>
-            <a:fillRect/>
-          </a:stretch>
-        </p:blipFill>
-        <p:spPr>
-          <a:xfrm>
-            <a:off x="0" y="0"/>
-            <a:ext cx="12191999" cy="6858000"/>
-          </a:xfrm>
-          <a:prstGeom prst="rect">
-            <a:avLst/>
-          </a:prstGeom>
-        </p:spPr>
-      </p:pic>
-      <p:sp>
-        <p:nvSpPr>
-          <p:cNvPr id="3" name="Rectangle 2">
-            <a:hlinkClick r:id="rId3"/>
-          </p:cNvPr>
-          <p:cNvSpPr/>
-          <p:nvPr/>
-        </p:nvSpPr>
-        <p:spPr>
-          <a:xfrm>
-            <a:off x="9509760" y="384048"/>
-            <a:ext cx="1828800" cy="310896"/>
-          </a:xfrm>
-          <a:prstGeom prst="rect">
-            <a:avLst/>
-          </a:prstGeom>
-          <a:noFill/>
-          <a:ln>
-            <a:noFill/>
-          </a:ln>
-        </p:spPr>
-        <p:style>
-          <a:lnRef idx="1">
-            <a:schemeClr val="accent1"/>
-          </a:lnRef>
-          <a:fillRef idx="3">
-            <a:schemeClr val="accent1"/>
-          </a:fillRef>
-          <a:effectRef idx="2">
-            <a:schemeClr val="accent1"/>
-          </a:effectRef>
-          <a:fontRef idx="minor">
-            <a:schemeClr val="lt1"/>
-          </a:fontRef>
-        </p:style>
-        <p:txBody>
-          <a:bodyPr rtlCol="0" anchor="ctr"/>
-          <a:lstStyle/>
-          <a:p>
-            <a:pPr algn="ctr"/>
-          </a:p>
-        </p:txBody>
-      </p:sp>
-      <p:sp>
-        <p:nvSpPr>
-          <p:cNvPr id="4" name="Rectangle 3">
-            <a:hlinkClick r:id="rId3"/>
-          </p:cNvPr>
-          <p:cNvSpPr/>
-          <p:nvPr/>
-        </p:nvSpPr>
-        <p:spPr>
-          <a:xfrm>
-            <a:off x="6400800" y="6473952"/>
-            <a:ext cx="4937760" cy="201168"/>
-          </a:xfrm>
-          <a:prstGeom prst="rect">
-            <a:avLst/>
-          </a:prstGeom>
-          <a:noFill/>
-          <a:ln>
-            <a:noFill/>
-          </a:ln>
-        </p:spPr>
-        <p:style>
-          <a:lnRef idx="1">
-            <a:schemeClr val="accent1"/>
-          </a:lnRef>
-          <a:fillRef idx="3">
-            <a:schemeClr val="accent1"/>
-          </a:fillRef>
-          <a:effectRef idx="2">
-            <a:schemeClr val="accent1"/>
-          </a:effectRef>
-          <a:fontRef idx="minor">
-            <a:schemeClr val="lt1"/>
-          </a:fontRef>
-        </p:style>
-        <p:txBody>
-          <a:bodyPr rtlCol="0" anchor="ctr"/>
-          <a:lstStyle/>
-          <a:p>
-            <a:pPr algn="ctr"/>
-          </a:p>
-        </p:txBody>
-      </p:sp>
-    </p:spTree>
-  </p:cSld>
-  <p:clrMapOvr>
-    <a:masterClrMapping/>
-  </p:clrMapOvr>
-</p:sld>
-</file>
-
-<file path=ppt/slides/slide9.xml><?xml version="1.0" encoding="utf-8"?>
-<p:sld xmlns:a="http://schemas.openxmlformats.org/drawingml/2006/main" xmlns:p="http://schemas.openxmlformats.org/presentationml/2006/main" xmlns:r="http://schemas.openxmlformats.org/officeDocument/2006/relationships">
-  <p:cSld>
-    <p:spTree>
-      <p:nvGrpSpPr>
-        <p:cNvPr id="1" name=""/>
-        <p:cNvGrpSpPr/>
-        <p:nvPr/>
-      </p:nvGrpSpPr>
-      <p:grpSpPr/>
-      <p:pic>
-        <p:nvPicPr>
-          <p:cNvPr id="2" name="Picture 1" descr="slide-009.png"/>
-          <p:cNvPicPr>
-            <a:picLocks noChangeAspect="1"/>
-          </p:cNvPicPr>
-          <p:nvPr/>
-        </p:nvPicPr>
-        <p:blipFill>
-          <a:blip r:embed="rId2"/>
-          <a:stretch>
-            <a:fillRect/>
-          </a:stretch>
-        </p:blipFill>
-        <p:spPr>
-          <a:xfrm>
-            <a:off x="0" y="0"/>
-            <a:ext cx="12191999" cy="6858000"/>
-          </a:xfrm>
-          <a:prstGeom prst="rect">
-            <a:avLst/>
-          </a:prstGeom>
-        </p:spPr>
-      </p:pic>
-      <p:sp>
-        <p:nvSpPr>
-          <p:cNvPr id="3" name="Rectangle 2">
-            <a:hlinkClick r:id="rId3"/>
-          </p:cNvPr>
-          <p:cNvSpPr/>
-          <p:nvPr/>
-        </p:nvSpPr>
-        <p:spPr>
-          <a:xfrm>
-            <a:off x="9509760" y="384048"/>
-            <a:ext cx="1828800" cy="310896"/>
-          </a:xfrm>
-          <a:prstGeom prst="rect">
-            <a:avLst/>
-          </a:prstGeom>
-          <a:noFill/>
-          <a:ln>
-            <a:noFill/>
-          </a:ln>
-        </p:spPr>
-        <p:style>
-          <a:lnRef idx="1">
-            <a:schemeClr val="accent1"/>
-          </a:lnRef>
-          <a:fillRef idx="3">
-            <a:schemeClr val="accent1"/>
-          </a:fillRef>
-          <a:effectRef idx="2">
-            <a:schemeClr val="accent1"/>
-          </a:effectRef>
-          <a:fontRef idx="minor">
-            <a:schemeClr val="lt1"/>
-          </a:fontRef>
-        </p:style>
-        <p:txBody>
-          <a:bodyPr rtlCol="0" anchor="ctr"/>
-          <a:lstStyle/>
-          <a:p>
-            <a:pPr algn="ctr"/>
-          </a:p>
-        </p:txBody>
-      </p:sp>
-      <p:sp>
-        <p:nvSpPr>
-          <p:cNvPr id="4" name="Rectangle 3">
-            <a:hlinkClick r:id="rId3"/>
-          </p:cNvPr>
-          <p:cNvSpPr/>
-          <p:nvPr/>
-        </p:nvSpPr>
-        <p:spPr>
-          <a:xfrm>
-            <a:off x="6400800" y="6473952"/>
-            <a:ext cx="4937760" cy="201168"/>
-          </a:xfrm>
-          <a:prstGeom prst="rect">
-            <a:avLst/>
-          </a:prstGeom>
-          <a:noFill/>
-          <a:ln>
-            <a:noFill/>
-          </a:ln>
-        </p:spPr>
-        <p:style>
-          <a:lnRef idx="1">
-            <a:schemeClr val="accent1"/>
-          </a:lnRef>
-          <a:fillRef idx="3">
-            <a:schemeClr val="accent1"/>
-          </a:fillRef>
-          <a:effectRef idx="2">
-            <a:schemeClr val="accent1"/>
-          </a:effectRef>
-          <a:fontRef idx="minor">
-            <a:schemeClr val="lt1"/>
-          </a:fontRef>
-        </p:style>
-        <p:txBody>
-          <a:bodyPr rtlCol="0" anchor="ctr"/>
-          <a:lstStyle/>
-          <a:p>
-            <a:pPr algn="ctr"/>
-          </a:p>
-        </p:txBody>
-      </p:sp>
     </p:spTree>
   </p:cSld>
   <p:clrMapOvr>

</xml_diff>

<commit_message>
Update PubMed lymphoma slides 2026-06-08 refresh
</commit_message>
<xml_diff>
--- a/archive/2026-06-08/pubmed-dlbcl-cnsl-btki-2026-06-08.pptx
+++ b/archive/2026-06-08/pubmed-dlbcl-cnsl-btki-2026-06-08.pptx
@@ -5,15 +5,15 @@
     <p:sldMasterId id="2147483648" r:id="rId1"/>
   </p:sldMasterIdLst>
   <p:sldIdLst>
-    <p:sldId id="256" r:id="rId2"/>
-    <p:sldId id="257" r:id="rId3"/>
-    <p:sldId id="258" r:id="rId4"/>
-    <p:sldId id="259" r:id="rId5"/>
-    <p:sldId id="260" r:id="rId6"/>
-    <p:sldId id="261" r:id="rId7"/>
-    <p:sldId id="262" r:id="rId8"/>
+    <p:sldId id="256" r:id="rId7"/>
+    <p:sldId id="257" r:id="rId8"/>
+    <p:sldId id="258" r:id="rId9"/>
+    <p:sldId id="259" r:id="rId10"/>
+    <p:sldId id="260" r:id="rId11"/>
+    <p:sldId id="261" r:id="rId12"/>
+    <p:sldId id="262" r:id="rId13"/>
   </p:sldIdLst>
-  <p:sldSz cx="12192000" cy="6858000"/>
+  <p:sldSz cx="12191999" cy="6858000" type="screen4x3"/>
   <p:notesSz cx="6858000" cy="9144000"/>
   <p:defaultTextStyle>
     <a:defPPr>
@@ -110,22 +110,6 @@
       </a:defRPr>
     </a:lvl9pPr>
   </p:defaultTextStyle>
-  <p:extLst>
-    <p:ext uri="{EFAFB233-063F-42B5-8137-9DF3F51BA10A}">
-      <p15:sldGuideLst xmlns:p15="http://schemas.microsoft.com/office/powerpoint/2012/main">
-        <p15:guide id="1" orient="horz" pos="2160">
-          <p15:clr>
-            <a:srgbClr val="A4A3A4"/>
-          </p15:clr>
-        </p15:guide>
-        <p15:guide id="2" pos="2880">
-          <p15:clr>
-            <a:srgbClr val="A4A3A4"/>
-          </p15:clr>
-        </p15:guide>
-      </p15:sldGuideLst>
-    </p:ext>
-  </p:extLst>
 </p:presentation>
 </file>
 
@@ -167,9 +151,10 @@
           <a:lstStyle/>
           <a:p>
             <a:r>
-              <a:rPr lang="en-US"/>
+              <a:rPr lang="en-US" smtClean="0"/>
               <a:t>Click to edit Master title style</a:t>
             </a:r>
+            <a:endParaRPr lang="en-US"/>
           </a:p>
         </p:txBody>
       </p:sp>
@@ -285,9 +270,10 @@
           </a:lstStyle>
           <a:p>
             <a:r>
-              <a:rPr lang="en-US"/>
+              <a:rPr lang="en-US" smtClean="0"/>
               <a:t>Click to edit Master subtitle style</a:t>
             </a:r>
+            <a:endParaRPr lang="en-US"/>
           </a:p>
         </p:txBody>
       </p:sp>
@@ -308,7 +294,7 @@
           <a:p>
             <a:fld id="{5BCAD085-E8A6-8845-BD4E-CB4CCA059FC4}" type="datetimeFigureOut">
               <a:rPr lang="en-US" smtClean="0"/>
-              <a:t>6/8/2026</a:t>
+              <a:t>1/27/13</a:t>
             </a:fld>
             <a:endParaRPr lang="en-US"/>
           </a:p>
@@ -402,9 +388,10 @@
           <a:lstStyle/>
           <a:p>
             <a:r>
-              <a:rPr lang="en-US"/>
+              <a:rPr lang="en-US" smtClean="0"/>
               <a:t>Click to edit Master title style</a:t>
             </a:r>
+            <a:endParaRPr lang="en-US"/>
           </a:p>
         </p:txBody>
       </p:sp>
@@ -425,37 +412,38 @@
           <a:p>
             <a:pPr lvl="0"/>
             <a:r>
-              <a:rPr lang="en-US"/>
+              <a:rPr lang="en-US" smtClean="0"/>
               <a:t>Click to edit Master text styles</a:t>
             </a:r>
           </a:p>
           <a:p>
             <a:pPr lvl="1"/>
             <a:r>
-              <a:rPr lang="en-US"/>
+              <a:rPr lang="en-US" smtClean="0"/>
               <a:t>Second level</a:t>
             </a:r>
           </a:p>
           <a:p>
             <a:pPr lvl="2"/>
             <a:r>
-              <a:rPr lang="en-US"/>
+              <a:rPr lang="en-US" smtClean="0"/>
               <a:t>Third level</a:t>
             </a:r>
           </a:p>
           <a:p>
             <a:pPr lvl="3"/>
             <a:r>
-              <a:rPr lang="en-US"/>
+              <a:rPr lang="en-US" smtClean="0"/>
               <a:t>Fourth level</a:t>
             </a:r>
           </a:p>
           <a:p>
             <a:pPr lvl="4"/>
             <a:r>
-              <a:rPr lang="en-US"/>
+              <a:rPr lang="en-US" smtClean="0"/>
               <a:t>Fifth level</a:t>
             </a:r>
+            <a:endParaRPr lang="en-US"/>
           </a:p>
         </p:txBody>
       </p:sp>
@@ -476,7 +464,7 @@
           <a:p>
             <a:fld id="{5BCAD085-E8A6-8845-BD4E-CB4CCA059FC4}" type="datetimeFigureOut">
               <a:rPr lang="en-US" smtClean="0"/>
-              <a:t>6/8/2026</a:t>
+              <a:t>1/27/13</a:t>
             </a:fld>
             <a:endParaRPr lang="en-US"/>
           </a:p>
@@ -575,9 +563,10 @@
           <a:lstStyle/>
           <a:p>
             <a:r>
-              <a:rPr lang="en-US"/>
+              <a:rPr lang="en-US" smtClean="0"/>
               <a:t>Click to edit Master title style</a:t>
             </a:r>
+            <a:endParaRPr lang="en-US"/>
           </a:p>
         </p:txBody>
       </p:sp>
@@ -603,37 +592,38 @@
           <a:p>
             <a:pPr lvl="0"/>
             <a:r>
-              <a:rPr lang="en-US"/>
+              <a:rPr lang="en-US" smtClean="0"/>
               <a:t>Click to edit Master text styles</a:t>
             </a:r>
           </a:p>
           <a:p>
             <a:pPr lvl="1"/>
             <a:r>
-              <a:rPr lang="en-US"/>
+              <a:rPr lang="en-US" smtClean="0"/>
               <a:t>Second level</a:t>
             </a:r>
           </a:p>
           <a:p>
             <a:pPr lvl="2"/>
             <a:r>
-              <a:rPr lang="en-US"/>
+              <a:rPr lang="en-US" smtClean="0"/>
               <a:t>Third level</a:t>
             </a:r>
           </a:p>
           <a:p>
             <a:pPr lvl="3"/>
             <a:r>
-              <a:rPr lang="en-US"/>
+              <a:rPr lang="en-US" smtClean="0"/>
               <a:t>Fourth level</a:t>
             </a:r>
           </a:p>
           <a:p>
             <a:pPr lvl="4"/>
             <a:r>
-              <a:rPr lang="en-US"/>
+              <a:rPr lang="en-US" smtClean="0"/>
               <a:t>Fifth level</a:t>
             </a:r>
+            <a:endParaRPr lang="en-US"/>
           </a:p>
         </p:txBody>
       </p:sp>
@@ -654,7 +644,7 @@
           <a:p>
             <a:fld id="{5BCAD085-E8A6-8845-BD4E-CB4CCA059FC4}" type="datetimeFigureOut">
               <a:rPr lang="en-US" smtClean="0"/>
-              <a:t>6/8/2026</a:t>
+              <a:t>1/27/13</a:t>
             </a:fld>
             <a:endParaRPr lang="en-US"/>
           </a:p>
@@ -748,9 +738,10 @@
           <a:lstStyle/>
           <a:p>
             <a:r>
-              <a:rPr lang="en-US"/>
+              <a:rPr lang="en-US" smtClean="0"/>
               <a:t>Click to edit Master title style</a:t>
             </a:r>
+            <a:endParaRPr lang="en-US"/>
           </a:p>
         </p:txBody>
       </p:sp>
@@ -771,37 +762,38 @@
           <a:p>
             <a:pPr lvl="0"/>
             <a:r>
-              <a:rPr lang="en-US"/>
+              <a:rPr lang="en-US" smtClean="0"/>
               <a:t>Click to edit Master text styles</a:t>
             </a:r>
           </a:p>
           <a:p>
             <a:pPr lvl="1"/>
             <a:r>
-              <a:rPr lang="en-US"/>
+              <a:rPr lang="en-US" smtClean="0"/>
               <a:t>Second level</a:t>
             </a:r>
           </a:p>
           <a:p>
             <a:pPr lvl="2"/>
             <a:r>
-              <a:rPr lang="en-US"/>
+              <a:rPr lang="en-US" smtClean="0"/>
               <a:t>Third level</a:t>
             </a:r>
           </a:p>
           <a:p>
             <a:pPr lvl="3"/>
             <a:r>
-              <a:rPr lang="en-US"/>
+              <a:rPr lang="en-US" smtClean="0"/>
               <a:t>Fourth level</a:t>
             </a:r>
           </a:p>
           <a:p>
             <a:pPr lvl="4"/>
             <a:r>
-              <a:rPr lang="en-US"/>
+              <a:rPr lang="en-US" smtClean="0"/>
               <a:t>Fifth level</a:t>
             </a:r>
+            <a:endParaRPr lang="en-US"/>
           </a:p>
         </p:txBody>
       </p:sp>
@@ -822,7 +814,7 @@
           <a:p>
             <a:fld id="{5BCAD085-E8A6-8845-BD4E-CB4CCA059FC4}" type="datetimeFigureOut">
               <a:rPr lang="en-US" smtClean="0"/>
-              <a:t>6/8/2026</a:t>
+              <a:t>1/27/13</a:t>
             </a:fld>
             <a:endParaRPr lang="en-US"/>
           </a:p>
@@ -925,9 +917,10 @@
           </a:lstStyle>
           <a:p>
             <a:r>
-              <a:rPr lang="en-US"/>
+              <a:rPr lang="en-US" smtClean="0"/>
               <a:t>Click to edit Master title style</a:t>
             </a:r>
+            <a:endParaRPr lang="en-US"/>
           </a:p>
         </p:txBody>
       </p:sp>
@@ -1044,7 +1037,7 @@
           <a:p>
             <a:pPr lvl="0"/>
             <a:r>
-              <a:rPr lang="en-US"/>
+              <a:rPr lang="en-US" smtClean="0"/>
               <a:t>Click to edit Master text styles</a:t>
             </a:r>
           </a:p>
@@ -1067,7 +1060,7 @@
           <a:p>
             <a:fld id="{5BCAD085-E8A6-8845-BD4E-CB4CCA059FC4}" type="datetimeFigureOut">
               <a:rPr lang="en-US" smtClean="0"/>
-              <a:t>6/8/2026</a:t>
+              <a:t>1/27/13</a:t>
             </a:fld>
             <a:endParaRPr lang="en-US"/>
           </a:p>
@@ -1161,9 +1154,10 @@
           <a:lstStyle/>
           <a:p>
             <a:r>
-              <a:rPr lang="en-US"/>
+              <a:rPr lang="en-US" smtClean="0"/>
               <a:t>Click to edit Master title style</a:t>
             </a:r>
+            <a:endParaRPr lang="en-US"/>
           </a:p>
         </p:txBody>
       </p:sp>
@@ -1217,37 +1211,38 @@
           <a:p>
             <a:pPr lvl="0"/>
             <a:r>
-              <a:rPr lang="en-US"/>
+              <a:rPr lang="en-US" smtClean="0"/>
               <a:t>Click to edit Master text styles</a:t>
             </a:r>
           </a:p>
           <a:p>
             <a:pPr lvl="1"/>
             <a:r>
-              <a:rPr lang="en-US"/>
+              <a:rPr lang="en-US" smtClean="0"/>
               <a:t>Second level</a:t>
             </a:r>
           </a:p>
           <a:p>
             <a:pPr lvl="2"/>
             <a:r>
-              <a:rPr lang="en-US"/>
+              <a:rPr lang="en-US" smtClean="0"/>
               <a:t>Third level</a:t>
             </a:r>
           </a:p>
           <a:p>
             <a:pPr lvl="3"/>
             <a:r>
-              <a:rPr lang="en-US"/>
+              <a:rPr lang="en-US" smtClean="0"/>
               <a:t>Fourth level</a:t>
             </a:r>
           </a:p>
           <a:p>
             <a:pPr lvl="4"/>
             <a:r>
-              <a:rPr lang="en-US"/>
+              <a:rPr lang="en-US" smtClean="0"/>
               <a:t>Fifth level</a:t>
             </a:r>
+            <a:endParaRPr lang="en-US"/>
           </a:p>
         </p:txBody>
       </p:sp>
@@ -1301,37 +1296,38 @@
           <a:p>
             <a:pPr lvl="0"/>
             <a:r>
-              <a:rPr lang="en-US"/>
+              <a:rPr lang="en-US" smtClean="0"/>
               <a:t>Click to edit Master text styles</a:t>
             </a:r>
           </a:p>
           <a:p>
             <a:pPr lvl="1"/>
             <a:r>
-              <a:rPr lang="en-US"/>
+              <a:rPr lang="en-US" smtClean="0"/>
               <a:t>Second level</a:t>
             </a:r>
           </a:p>
           <a:p>
             <a:pPr lvl="2"/>
             <a:r>
-              <a:rPr lang="en-US"/>
+              <a:rPr lang="en-US" smtClean="0"/>
               <a:t>Third level</a:t>
             </a:r>
           </a:p>
           <a:p>
             <a:pPr lvl="3"/>
             <a:r>
-              <a:rPr lang="en-US"/>
+              <a:rPr lang="en-US" smtClean="0"/>
               <a:t>Fourth level</a:t>
             </a:r>
           </a:p>
           <a:p>
             <a:pPr lvl="4"/>
             <a:r>
-              <a:rPr lang="en-US"/>
+              <a:rPr lang="en-US" smtClean="0"/>
               <a:t>Fifth level</a:t>
             </a:r>
+            <a:endParaRPr lang="en-US"/>
           </a:p>
         </p:txBody>
       </p:sp>
@@ -1352,7 +1348,7 @@
           <a:p>
             <a:fld id="{5BCAD085-E8A6-8845-BD4E-CB4CCA059FC4}" type="datetimeFigureOut">
               <a:rPr lang="en-US" smtClean="0"/>
-              <a:t>6/8/2026</a:t>
+              <a:t>1/27/13</a:t>
             </a:fld>
             <a:endParaRPr lang="en-US"/>
           </a:p>
@@ -1450,9 +1446,10 @@
           </a:lstStyle>
           <a:p>
             <a:r>
-              <a:rPr lang="en-US"/>
+              <a:rPr lang="en-US" smtClean="0"/>
               <a:t>Click to edit Master title style</a:t>
             </a:r>
+            <a:endParaRPr lang="en-US"/>
           </a:p>
         </p:txBody>
       </p:sp>
@@ -1515,7 +1512,7 @@
           <a:p>
             <a:pPr lvl="0"/>
             <a:r>
-              <a:rPr lang="en-US"/>
+              <a:rPr lang="en-US" smtClean="0"/>
               <a:t>Click to edit Master text styles</a:t>
             </a:r>
           </a:p>
@@ -1571,37 +1568,38 @@
           <a:p>
             <a:pPr lvl="0"/>
             <a:r>
-              <a:rPr lang="en-US"/>
+              <a:rPr lang="en-US" smtClean="0"/>
               <a:t>Click to edit Master text styles</a:t>
             </a:r>
           </a:p>
           <a:p>
             <a:pPr lvl="1"/>
             <a:r>
-              <a:rPr lang="en-US"/>
+              <a:rPr lang="en-US" smtClean="0"/>
               <a:t>Second level</a:t>
             </a:r>
           </a:p>
           <a:p>
             <a:pPr lvl="2"/>
             <a:r>
-              <a:rPr lang="en-US"/>
+              <a:rPr lang="en-US" smtClean="0"/>
               <a:t>Third level</a:t>
             </a:r>
           </a:p>
           <a:p>
             <a:pPr lvl="3"/>
             <a:r>
-              <a:rPr lang="en-US"/>
+              <a:rPr lang="en-US" smtClean="0"/>
               <a:t>Fourth level</a:t>
             </a:r>
           </a:p>
           <a:p>
             <a:pPr lvl="4"/>
             <a:r>
-              <a:rPr lang="en-US"/>
+              <a:rPr lang="en-US" smtClean="0"/>
               <a:t>Fifth level</a:t>
             </a:r>
+            <a:endParaRPr lang="en-US"/>
           </a:p>
         </p:txBody>
       </p:sp>
@@ -1664,7 +1662,7 @@
           <a:p>
             <a:pPr lvl="0"/>
             <a:r>
-              <a:rPr lang="en-US"/>
+              <a:rPr lang="en-US" smtClean="0"/>
               <a:t>Click to edit Master text styles</a:t>
             </a:r>
           </a:p>
@@ -1720,37 +1718,38 @@
           <a:p>
             <a:pPr lvl="0"/>
             <a:r>
-              <a:rPr lang="en-US"/>
+              <a:rPr lang="en-US" smtClean="0"/>
               <a:t>Click to edit Master text styles</a:t>
             </a:r>
           </a:p>
           <a:p>
             <a:pPr lvl="1"/>
             <a:r>
-              <a:rPr lang="en-US"/>
+              <a:rPr lang="en-US" smtClean="0"/>
               <a:t>Second level</a:t>
             </a:r>
           </a:p>
           <a:p>
             <a:pPr lvl="2"/>
             <a:r>
-              <a:rPr lang="en-US"/>
+              <a:rPr lang="en-US" smtClean="0"/>
               <a:t>Third level</a:t>
             </a:r>
           </a:p>
           <a:p>
             <a:pPr lvl="3"/>
             <a:r>
-              <a:rPr lang="en-US"/>
+              <a:rPr lang="en-US" smtClean="0"/>
               <a:t>Fourth level</a:t>
             </a:r>
           </a:p>
           <a:p>
             <a:pPr lvl="4"/>
             <a:r>
-              <a:rPr lang="en-US"/>
+              <a:rPr lang="en-US" smtClean="0"/>
               <a:t>Fifth level</a:t>
             </a:r>
+            <a:endParaRPr lang="en-US"/>
           </a:p>
         </p:txBody>
       </p:sp>
@@ -1771,7 +1770,7 @@
           <a:p>
             <a:fld id="{5BCAD085-E8A6-8845-BD4E-CB4CCA059FC4}" type="datetimeFigureOut">
               <a:rPr lang="en-US" smtClean="0"/>
-              <a:t>6/8/2026</a:t>
+              <a:t>1/27/13</a:t>
             </a:fld>
             <a:endParaRPr lang="en-US"/>
           </a:p>
@@ -1865,9 +1864,10 @@
           <a:lstStyle/>
           <a:p>
             <a:r>
-              <a:rPr lang="en-US"/>
+              <a:rPr lang="en-US" smtClean="0"/>
               <a:t>Click to edit Master title style</a:t>
             </a:r>
+            <a:endParaRPr lang="en-US"/>
           </a:p>
         </p:txBody>
       </p:sp>
@@ -1888,7 +1888,7 @@
           <a:p>
             <a:fld id="{5BCAD085-E8A6-8845-BD4E-CB4CCA059FC4}" type="datetimeFigureOut">
               <a:rPr lang="en-US" smtClean="0"/>
-              <a:t>6/8/2026</a:t>
+              <a:t>1/27/13</a:t>
             </a:fld>
             <a:endParaRPr lang="en-US"/>
           </a:p>
@@ -1983,7 +1983,7 @@
           <a:p>
             <a:fld id="{5BCAD085-E8A6-8845-BD4E-CB4CCA059FC4}" type="datetimeFigureOut">
               <a:rPr lang="en-US" smtClean="0"/>
-              <a:t>6/8/2026</a:t>
+              <a:t>1/27/13</a:t>
             </a:fld>
             <a:endParaRPr lang="en-US"/>
           </a:p>
@@ -2086,9 +2086,10 @@
           </a:lstStyle>
           <a:p>
             <a:r>
-              <a:rPr lang="en-US"/>
+              <a:rPr lang="en-US" smtClean="0"/>
               <a:t>Click to edit Master title style</a:t>
             </a:r>
+            <a:endParaRPr lang="en-US"/>
           </a:p>
         </p:txBody>
       </p:sp>
@@ -2142,37 +2143,38 @@
           <a:p>
             <a:pPr lvl="0"/>
             <a:r>
-              <a:rPr lang="en-US"/>
+              <a:rPr lang="en-US" smtClean="0"/>
               <a:t>Click to edit Master text styles</a:t>
             </a:r>
           </a:p>
           <a:p>
             <a:pPr lvl="1"/>
             <a:r>
-              <a:rPr lang="en-US"/>
+              <a:rPr lang="en-US" smtClean="0"/>
               <a:t>Second level</a:t>
             </a:r>
           </a:p>
           <a:p>
             <a:pPr lvl="2"/>
             <a:r>
-              <a:rPr lang="en-US"/>
+              <a:rPr lang="en-US" smtClean="0"/>
               <a:t>Third level</a:t>
             </a:r>
           </a:p>
           <a:p>
             <a:pPr lvl="3"/>
             <a:r>
-              <a:rPr lang="en-US"/>
+              <a:rPr lang="en-US" smtClean="0"/>
               <a:t>Fourth level</a:t>
             </a:r>
           </a:p>
           <a:p>
             <a:pPr lvl="4"/>
             <a:r>
-              <a:rPr lang="en-US"/>
+              <a:rPr lang="en-US" smtClean="0"/>
               <a:t>Fifth level</a:t>
             </a:r>
+            <a:endParaRPr lang="en-US"/>
           </a:p>
         </p:txBody>
       </p:sp>
@@ -2235,7 +2237,7 @@
           <a:p>
             <a:pPr lvl="0"/>
             <a:r>
-              <a:rPr lang="en-US"/>
+              <a:rPr lang="en-US" smtClean="0"/>
               <a:t>Click to edit Master text styles</a:t>
             </a:r>
           </a:p>
@@ -2258,7 +2260,7 @@
           <a:p>
             <a:fld id="{5BCAD085-E8A6-8845-BD4E-CB4CCA059FC4}" type="datetimeFigureOut">
               <a:rPr lang="en-US" smtClean="0"/>
-              <a:t>6/8/2026</a:t>
+              <a:t>1/27/13</a:t>
             </a:fld>
             <a:endParaRPr lang="en-US"/>
           </a:p>
@@ -2361,9 +2363,10 @@
           </a:lstStyle>
           <a:p>
             <a:r>
-              <a:rPr lang="en-US"/>
+              <a:rPr lang="en-US" smtClean="0"/>
               <a:t>Click to edit Master title style</a:t>
             </a:r>
+            <a:endParaRPr lang="en-US"/>
           </a:p>
         </p:txBody>
       </p:sp>
@@ -2487,7 +2490,7 @@
           <a:p>
             <a:pPr lvl="0"/>
             <a:r>
-              <a:rPr lang="en-US"/>
+              <a:rPr lang="en-US" smtClean="0"/>
               <a:t>Click to edit Master text styles</a:t>
             </a:r>
           </a:p>
@@ -2510,7 +2513,7 @@
           <a:p>
             <a:fld id="{5BCAD085-E8A6-8845-BD4E-CB4CCA059FC4}" type="datetimeFigureOut">
               <a:rPr lang="en-US" smtClean="0"/>
-              <a:t>6/8/2026</a:t>
+              <a:t>1/27/13</a:t>
             </a:fld>
             <a:endParaRPr lang="en-US"/>
           </a:p>
@@ -2619,9 +2622,10 @@
           <a:lstStyle/>
           <a:p>
             <a:r>
-              <a:rPr lang="en-US"/>
+              <a:rPr lang="en-US" smtClean="0"/>
               <a:t>Click to edit Master title style</a:t>
             </a:r>
+            <a:endParaRPr lang="en-US"/>
           </a:p>
         </p:txBody>
       </p:sp>
@@ -2652,37 +2656,38 @@
           <a:p>
             <a:pPr lvl="0"/>
             <a:r>
-              <a:rPr lang="en-US"/>
+              <a:rPr lang="en-US" smtClean="0"/>
               <a:t>Click to edit Master text styles</a:t>
             </a:r>
           </a:p>
           <a:p>
             <a:pPr lvl="1"/>
             <a:r>
-              <a:rPr lang="en-US"/>
+              <a:rPr lang="en-US" smtClean="0"/>
               <a:t>Second level</a:t>
             </a:r>
           </a:p>
           <a:p>
             <a:pPr lvl="2"/>
             <a:r>
-              <a:rPr lang="en-US"/>
+              <a:rPr lang="en-US" smtClean="0"/>
               <a:t>Third level</a:t>
             </a:r>
           </a:p>
           <a:p>
             <a:pPr lvl="3"/>
             <a:r>
-              <a:rPr lang="en-US"/>
+              <a:rPr lang="en-US" smtClean="0"/>
               <a:t>Fourth level</a:t>
             </a:r>
           </a:p>
           <a:p>
             <a:pPr lvl="4"/>
             <a:r>
-              <a:rPr lang="en-US"/>
+              <a:rPr lang="en-US" smtClean="0"/>
               <a:t>Fifth level</a:t>
             </a:r>
+            <a:endParaRPr lang="en-US"/>
           </a:p>
         </p:txBody>
       </p:sp>
@@ -2721,7 +2726,7 @@
           <a:p>
             <a:fld id="{5BCAD085-E8A6-8845-BD4E-CB4CCA059FC4}" type="datetimeFigureOut">
               <a:rPr lang="en-US" smtClean="0"/>
-              <a:t>6/8/2026</a:t>
+              <a:t>1/27/13</a:t>
             </a:fld>
             <a:endParaRPr lang="en-US"/>
           </a:p>
@@ -3080,7 +3085,7 @@
 </file>
 
 <file path=ppt/slides/slide1.xml><?xml version="1.0" encoding="utf-8"?>
-<p:sld xmlns:a="http://schemas.openxmlformats.org/drawingml/2006/main" xmlns:r="http://schemas.openxmlformats.org/officeDocument/2006/relationships" xmlns:p="http://schemas.openxmlformats.org/presentationml/2006/main">
+<p:sld xmlns:a="http://schemas.openxmlformats.org/drawingml/2006/main" xmlns:p="http://schemas.openxmlformats.org/presentationml/2006/main" xmlns:r="http://schemas.openxmlformats.org/officeDocument/2006/relationships">
   <p:cSld>
     <p:spTree>
       <p:nvGrpSpPr>
@@ -3088,14 +3093,7 @@
         <p:cNvGrpSpPr/>
         <p:nvPr/>
       </p:nvGrpSpPr>
-      <p:grpSpPr>
-        <a:xfrm>
-          <a:off x="0" y="0"/>
-          <a:ext cx="0" cy="0"/>
-          <a:chOff x="0" y="0"/>
-          <a:chExt cx="0" cy="0"/>
-        </a:xfrm>
-      </p:grpSpPr>
+      <p:grpSpPr/>
       <p:pic>
         <p:nvPicPr>
           <p:cNvPr id="2" name="Picture 1" descr="slide-001.png"/>
@@ -3160,7 +3158,6 @@
           <a:lstStyle/>
           <a:p>
             <a:pPr algn="ctr"/>
-            <a:endParaRPr/>
           </a:p>
         </p:txBody>
       </p:sp>
@@ -3204,7 +3201,6 @@
           <a:lstStyle/>
           <a:p>
             <a:pPr algn="ctr"/>
-            <a:endParaRPr/>
           </a:p>
         </p:txBody>
       </p:sp>
@@ -3248,7 +3244,6 @@
           <a:lstStyle/>
           <a:p>
             <a:pPr algn="ctr"/>
-            <a:endParaRPr/>
           </a:p>
         </p:txBody>
       </p:sp>
@@ -3292,7 +3287,6 @@
           <a:lstStyle/>
           <a:p>
             <a:pPr algn="ctr"/>
-            <a:endParaRPr/>
           </a:p>
         </p:txBody>
       </p:sp>
@@ -3336,7 +3330,6 @@
           <a:lstStyle/>
           <a:p>
             <a:pPr algn="ctr"/>
-            <a:endParaRPr/>
           </a:p>
         </p:txBody>
       </p:sp>
@@ -3349,7 +3342,7 @@
 </file>
 
 <file path=ppt/slides/slide2.xml><?xml version="1.0" encoding="utf-8"?>
-<p:sld xmlns:a="http://schemas.openxmlformats.org/drawingml/2006/main" xmlns:r="http://schemas.openxmlformats.org/officeDocument/2006/relationships" xmlns:p="http://schemas.openxmlformats.org/presentationml/2006/main">
+<p:sld xmlns:a="http://schemas.openxmlformats.org/drawingml/2006/main" xmlns:p="http://schemas.openxmlformats.org/presentationml/2006/main" xmlns:r="http://schemas.openxmlformats.org/officeDocument/2006/relationships">
   <p:cSld>
     <p:spTree>
       <p:nvGrpSpPr>
@@ -3357,14 +3350,7 @@
         <p:cNvGrpSpPr/>
         <p:nvPr/>
       </p:nvGrpSpPr>
-      <p:grpSpPr>
-        <a:xfrm>
-          <a:off x="0" y="0"/>
-          <a:ext cx="0" cy="0"/>
-          <a:chOff x="0" y="0"/>
-          <a:chExt cx="0" cy="0"/>
-        </a:xfrm>
-      </p:grpSpPr>
+      <p:grpSpPr/>
       <p:pic>
         <p:nvPicPr>
           <p:cNvPr id="2" name="Picture 1" descr="slide-002.png"/>
@@ -3429,7 +3415,6 @@
           <a:lstStyle/>
           <a:p>
             <a:pPr algn="ctr"/>
-            <a:endParaRPr/>
           </a:p>
         </p:txBody>
       </p:sp>
@@ -3473,7 +3458,6 @@
           <a:lstStyle/>
           <a:p>
             <a:pPr algn="ctr"/>
-            <a:endParaRPr/>
           </a:p>
         </p:txBody>
       </p:sp>
@@ -3486,7 +3470,7 @@
 </file>
 
 <file path=ppt/slides/slide3.xml><?xml version="1.0" encoding="utf-8"?>
-<p:sld xmlns:a="http://schemas.openxmlformats.org/drawingml/2006/main" xmlns:r="http://schemas.openxmlformats.org/officeDocument/2006/relationships" xmlns:p="http://schemas.openxmlformats.org/presentationml/2006/main">
+<p:sld xmlns:a="http://schemas.openxmlformats.org/drawingml/2006/main" xmlns:p="http://schemas.openxmlformats.org/presentationml/2006/main" xmlns:r="http://schemas.openxmlformats.org/officeDocument/2006/relationships">
   <p:cSld>
     <p:spTree>
       <p:nvGrpSpPr>
@@ -3494,14 +3478,7 @@
         <p:cNvGrpSpPr/>
         <p:nvPr/>
       </p:nvGrpSpPr>
-      <p:grpSpPr>
-        <a:xfrm>
-          <a:off x="0" y="0"/>
-          <a:ext cx="0" cy="0"/>
-          <a:chOff x="0" y="0"/>
-          <a:chExt cx="0" cy="0"/>
-        </a:xfrm>
-      </p:grpSpPr>
+      <p:grpSpPr/>
       <p:pic>
         <p:nvPicPr>
           <p:cNvPr id="2" name="Picture 1" descr="slide-003.png"/>
@@ -3566,7 +3543,6 @@
           <a:lstStyle/>
           <a:p>
             <a:pPr algn="ctr"/>
-            <a:endParaRPr/>
           </a:p>
         </p:txBody>
       </p:sp>
@@ -3610,7 +3586,6 @@
           <a:lstStyle/>
           <a:p>
             <a:pPr algn="ctr"/>
-            <a:endParaRPr/>
           </a:p>
         </p:txBody>
       </p:sp>
@@ -3623,7 +3598,7 @@
 </file>
 
 <file path=ppt/slides/slide4.xml><?xml version="1.0" encoding="utf-8"?>
-<p:sld xmlns:a="http://schemas.openxmlformats.org/drawingml/2006/main" xmlns:r="http://schemas.openxmlformats.org/officeDocument/2006/relationships" xmlns:p="http://schemas.openxmlformats.org/presentationml/2006/main">
+<p:sld xmlns:a="http://schemas.openxmlformats.org/drawingml/2006/main" xmlns:p="http://schemas.openxmlformats.org/presentationml/2006/main" xmlns:r="http://schemas.openxmlformats.org/officeDocument/2006/relationships">
   <p:cSld>
     <p:spTree>
       <p:nvGrpSpPr>
@@ -3631,14 +3606,7 @@
         <p:cNvGrpSpPr/>
         <p:nvPr/>
       </p:nvGrpSpPr>
-      <p:grpSpPr>
-        <a:xfrm>
-          <a:off x="0" y="0"/>
-          <a:ext cx="0" cy="0"/>
-          <a:chOff x="0" y="0"/>
-          <a:chExt cx="0" cy="0"/>
-        </a:xfrm>
-      </p:grpSpPr>
+      <p:grpSpPr/>
       <p:pic>
         <p:nvPicPr>
           <p:cNvPr id="2" name="Picture 1" descr="slide-004.png"/>
@@ -3703,7 +3671,6 @@
           <a:lstStyle/>
           <a:p>
             <a:pPr algn="ctr"/>
-            <a:endParaRPr/>
           </a:p>
         </p:txBody>
       </p:sp>
@@ -3747,7 +3714,6 @@
           <a:lstStyle/>
           <a:p>
             <a:pPr algn="ctr"/>
-            <a:endParaRPr/>
           </a:p>
         </p:txBody>
       </p:sp>
@@ -3760,7 +3726,7 @@
 </file>
 
 <file path=ppt/slides/slide5.xml><?xml version="1.0" encoding="utf-8"?>
-<p:sld xmlns:a="http://schemas.openxmlformats.org/drawingml/2006/main" xmlns:r="http://schemas.openxmlformats.org/officeDocument/2006/relationships" xmlns:p="http://schemas.openxmlformats.org/presentationml/2006/main">
+<p:sld xmlns:a="http://schemas.openxmlformats.org/drawingml/2006/main" xmlns:p="http://schemas.openxmlformats.org/presentationml/2006/main" xmlns:r="http://schemas.openxmlformats.org/officeDocument/2006/relationships">
   <p:cSld>
     <p:spTree>
       <p:nvGrpSpPr>
@@ -3768,14 +3734,7 @@
         <p:cNvGrpSpPr/>
         <p:nvPr/>
       </p:nvGrpSpPr>
-      <p:grpSpPr>
-        <a:xfrm>
-          <a:off x="0" y="0"/>
-          <a:ext cx="0" cy="0"/>
-          <a:chOff x="0" y="0"/>
-          <a:chExt cx="0" cy="0"/>
-        </a:xfrm>
-      </p:grpSpPr>
+      <p:grpSpPr/>
       <p:pic>
         <p:nvPicPr>
           <p:cNvPr id="2" name="Picture 1" descr="slide-005.png"/>
@@ -3840,7 +3799,6 @@
           <a:lstStyle/>
           <a:p>
             <a:pPr algn="ctr"/>
-            <a:endParaRPr/>
           </a:p>
         </p:txBody>
       </p:sp>
@@ -3884,7 +3842,6 @@
           <a:lstStyle/>
           <a:p>
             <a:pPr algn="ctr"/>
-            <a:endParaRPr/>
           </a:p>
         </p:txBody>
       </p:sp>
@@ -3897,7 +3854,7 @@
 </file>
 
 <file path=ppt/slides/slide6.xml><?xml version="1.0" encoding="utf-8"?>
-<p:sld xmlns:a="http://schemas.openxmlformats.org/drawingml/2006/main" xmlns:r="http://schemas.openxmlformats.org/officeDocument/2006/relationships" xmlns:p="http://schemas.openxmlformats.org/presentationml/2006/main">
+<p:sld xmlns:a="http://schemas.openxmlformats.org/drawingml/2006/main" xmlns:p="http://schemas.openxmlformats.org/presentationml/2006/main" xmlns:r="http://schemas.openxmlformats.org/officeDocument/2006/relationships">
   <p:cSld>
     <p:spTree>
       <p:nvGrpSpPr>
@@ -3905,14 +3862,7 @@
         <p:cNvGrpSpPr/>
         <p:nvPr/>
       </p:nvGrpSpPr>
-      <p:grpSpPr>
-        <a:xfrm>
-          <a:off x="0" y="0"/>
-          <a:ext cx="0" cy="0"/>
-          <a:chOff x="0" y="0"/>
-          <a:chExt cx="0" cy="0"/>
-        </a:xfrm>
-      </p:grpSpPr>
+      <p:grpSpPr/>
       <p:pic>
         <p:nvPicPr>
           <p:cNvPr id="2" name="Picture 1" descr="slide-006.png"/>
@@ -3977,7 +3927,6 @@
           <a:lstStyle/>
           <a:p>
             <a:pPr algn="ctr"/>
-            <a:endParaRPr/>
           </a:p>
         </p:txBody>
       </p:sp>
@@ -4021,7 +3970,6 @@
           <a:lstStyle/>
           <a:p>
             <a:pPr algn="ctr"/>
-            <a:endParaRPr/>
           </a:p>
         </p:txBody>
       </p:sp>
@@ -4034,7 +3982,7 @@
 </file>
 
 <file path=ppt/slides/slide7.xml><?xml version="1.0" encoding="utf-8"?>
-<p:sld xmlns:a="http://schemas.openxmlformats.org/drawingml/2006/main" xmlns:r="http://schemas.openxmlformats.org/officeDocument/2006/relationships" xmlns:p="http://schemas.openxmlformats.org/presentationml/2006/main">
+<p:sld xmlns:a="http://schemas.openxmlformats.org/drawingml/2006/main" xmlns:p="http://schemas.openxmlformats.org/presentationml/2006/main" xmlns:r="http://schemas.openxmlformats.org/officeDocument/2006/relationships">
   <p:cSld>
     <p:spTree>
       <p:nvGrpSpPr>
@@ -4042,14 +3990,7 @@
         <p:cNvGrpSpPr/>
         <p:nvPr/>
       </p:nvGrpSpPr>
-      <p:grpSpPr>
-        <a:xfrm>
-          <a:off x="0" y="0"/>
-          <a:ext cx="0" cy="0"/>
-          <a:chOff x="0" y="0"/>
-          <a:chExt cx="0" cy="0"/>
-        </a:xfrm>
-      </p:grpSpPr>
+      <p:grpSpPr/>
       <p:pic>
         <p:nvPicPr>
           <p:cNvPr id="2" name="Picture 1" descr="slide-007.png"/>

</xml_diff>